<commit_message>
feat: 사람 평가 UI(/revise) + auto↔human 상관 측정 + 발표 슬라이드
1) Next.js UI 별점+코멘트 위젯 → /revise 연결
   - src/app/api/agent-revise/route.ts: 에이전트 /revise JSON 프록시
   - agent-demo: FeedbackWidget(별점 5→10점, 코멘트) → 카드별 재생성,
     auto_score before→after 표시, 재생성 카드로 교체

2) 자동(art_director) ↔ 사람 점수 상관 측정
   - feedback_store.score_correlation(): Pearson/Spearman/MAE
   - GET /feedback/stats에 auto_vs_human 포함
   - measure_control.py --correlation CLI

3) 발표 덱에 human-in-the-loop 슬라이드 1장 추가 (총 15장)

테스트 22개 통과, TS 타입체크 통과

https://claude.ai/code/session_016Dtq5m66UpK1gJAd9RdgD6
</commit_message>
<xml_diff>
--- a/scratch/intentcard-cv-presentation.pptx
+++ b/scratch/intentcard-cv-presentation.pptx
@@ -19,9 +19,10 @@
     <p:sldId id="267" r:id="rId13"/>
     <p:sldId id="268" r:id="rId14"/>
     <p:sldId id="269" r:id="rId15"/>
+    <p:sldId id="270" r:id="rId16"/>
   </p:sldIdLst>
   <p:notesMasterIdLst>
-    <p:notesMasterId r:id="rId16"/>
+    <p:notesMasterId r:id="rId17"/>
   </p:notesMasterIdLst>
   <p:sldSz cx="12191695" cy="6858000"/>
   <p:notesSz cx="6858000" cy="12191695"/>
@@ -979,6 +980,94 @@
             <a:fld id="{F7021451-1387-4CA6-816F-3879F97B5CBC}" type="slidenum">
               <a:rPr lang="en-US"/>
               <a:t>14</a:t>
+            </a:fld>
+            <a:endParaRPr lang="en-US"/>
+          </a:p>
+        </p:txBody>
+      </p:sp>
+    </p:spTree>
+    <p:extLst>
+      <p:ext uri="{BB962C8B-B14F-4D97-AF65-F5344CB8AC3E}">
+        <p14:creationId xmlns:p14="http://schemas.microsoft.com/office/powerpoint/2010/main" val="1024086991"/>
+      </p:ext>
+    </p:extLst>
+  </p:cSld>
+  <p:clrMapOvr>
+    <a:masterClrMapping/>
+  </p:clrMapOvr>
+</p:notes>
+</file>
+
+<file path=ppt/notesSlides/notesSlide15.xml><?xml version="1.0" encoding="utf-8"?>
+<p:notes xmlns:a="http://schemas.openxmlformats.org/drawingml/2006/main" xmlns:r="http://schemas.openxmlformats.org/officeDocument/2006/relationships" xmlns:p="http://schemas.openxmlformats.org/presentationml/2006/main">
+  <p:cSld>
+    <p:spTree>
+      <p:nvGrpSpPr>
+        <p:cNvPr id="1" name=""/>
+        <p:cNvGrpSpPr/>
+        <p:nvPr/>
+      </p:nvGrpSpPr>
+      <p:grpSpPr>
+        <a:xfrm>
+          <a:off x="0" y="0"/>
+          <a:ext cx="0" cy="0"/>
+          <a:chOff x="0" y="0"/>
+          <a:chExt cx="0" cy="0"/>
+        </a:xfrm>
+      </p:grpSpPr>
+      <p:sp>
+        <p:nvSpPr>
+          <p:cNvPr id="2" name="Slide Image Placeholder 1"/>
+          <p:cNvSpPr>
+            <a:spLocks noGrp="1" noRot="1" noChangeAspect="1"/>
+          </p:cNvSpPr>
+          <p:nvPr>
+            <p:ph type="sldImg"/>
+          </p:nvPr>
+        </p:nvSpPr>
+        <p:spPr/>
+      </p:sp>
+      <p:sp>
+        <p:nvSpPr>
+          <p:cNvPr id="3" name="Notes Placeholder 2"/>
+          <p:cNvSpPr>
+            <a:spLocks noGrp="1"/>
+          </p:cNvSpPr>
+          <p:nvPr>
+            <p:ph type="body" idx="1"/>
+          </p:nvPr>
+        </p:nvSpPr>
+        <p:spPr/>
+        <p:txBody>
+          <a:bodyPr/>
+          <a:lstStyle/>
+          <a:p>
+            <a:r>
+              <a:rPr lang="en-US" dirty="0"/>
+              <a:t/>
+            </a:r>
+            <a:endParaRPr lang="en-US" dirty="0"/>
+          </a:p>
+        </p:txBody>
+      </p:sp>
+      <p:sp>
+        <p:nvSpPr>
+          <p:cNvPr id="4" name="Slide Number Placeholder 3"/>
+          <p:cNvSpPr>
+            <a:spLocks noGrp="1"/>
+          </p:cNvSpPr>
+          <p:nvPr>
+            <p:ph type="sldNum" sz="quarter" idx="10"/>
+          </p:nvPr>
+        </p:nvSpPr>
+        <p:spPr/>
+        <p:txBody>
+          <a:bodyPr/>
+          <a:lstStyle/>
+          <a:p>
+            <a:fld id="{F7021451-1387-4CA6-816F-3879F97B5CBC}" type="slidenum">
+              <a:rPr lang="en-US"/>
+              <a:t>15</a:t>
             </a:fld>
             <a:endParaRPr lang="en-US"/>
           </a:p>
@@ -4929,7 +5018,7 @@
                 <a:ea typeface="Pretendard" pitchFamily="34" charset="-122"/>
                 <a:cs typeface="Pretendard" pitchFamily="34" charset="-120"/>
               </a:rPr>
-              <a:t>LIMITATIONS · 개선할 점</a:t>
+              <a:t>HUMAN-IN-THE-LOOP · 사람 평가를 성능으로</a:t>
             </a:r>
             <a:endParaRPr lang="en-US" sz="1300" dirty="0"/>
           </a:p>
@@ -4963,7 +5052,7 @@
               <a:buNone/>
             </a:pPr>
             <a:r>
-              <a:rPr lang="en-US" sz="3000" b="1" dirty="0">
+              <a:rPr lang="en-US" sz="2500" b="1" dirty="0">
                 <a:solidFill>
                   <a:srgbClr val="F5F5F7"/>
                 </a:solidFill>
@@ -4971,9 +5060,43 @@
                 <a:ea typeface="Pretendard" pitchFamily="34" charset="-122"/>
                 <a:cs typeface="Pretendard" pitchFamily="34" charset="-120"/>
               </a:rPr>
-              <a:t>정직한 한계와 다음 과제</a:t>
-            </a:r>
-            <a:endParaRPr lang="en-US" sz="3000" dirty="0"/>
+              <a:t>사람의 별점이 </a:t>
+            </a:r>
+            <a:pPr algn="l" indent="0" marL="0">
+              <a:lnSpc>
+                <a:spcPts val="3600"/>
+              </a:lnSpc>
+              <a:buNone/>
+            </a:pPr>
+            <a:r>
+              <a:rPr lang="en-US" sz="2500" b="1" dirty="0">
+                <a:solidFill>
+                  <a:srgbClr val="FF7A45"/>
+                </a:solidFill>
+                <a:latin typeface="Pretendard" pitchFamily="34" charset="0"/>
+                <a:ea typeface="Pretendard" pitchFamily="34" charset="-122"/>
+                <a:cs typeface="Pretendard" pitchFamily="34" charset="-120"/>
+              </a:rPr>
+              <a:t>같은 self-correction 루프</a:t>
+            </a:r>
+            <a:pPr algn="l" indent="0" marL="0">
+              <a:lnSpc>
+                <a:spcPts val="3600"/>
+              </a:lnSpc>
+              <a:buNone/>
+            </a:pPr>
+            <a:r>
+              <a:rPr lang="en-US" sz="2500" b="1" dirty="0">
+                <a:solidFill>
+                  <a:srgbClr val="F5F5F7"/>
+                </a:solidFill>
+                <a:latin typeface="Pretendard" pitchFamily="34" charset="0"/>
+                <a:ea typeface="Pretendard" pitchFamily="34" charset="-122"/>
+                <a:cs typeface="Pretendard" pitchFamily="34" charset="-120"/>
+              </a:rPr>
+              <a:t>를 돌린다</a:t>
+            </a:r>
+            <a:endParaRPr lang="en-US" sz="2500" dirty="0"/>
           </a:p>
         </p:txBody>
       </p:sp>
@@ -4985,12 +5108,858 @@
         </p:nvSpPr>
         <p:spPr>
           <a:xfrm>
-            <a:off x="822960" y="2377440"/>
-            <a:ext cx="3383280" cy="3291840"/>
+            <a:off x="664312" y="2331720"/>
+            <a:ext cx="2011680" cy="1645920"/>
           </a:xfrm>
           <a:prstGeom prst="roundRect">
             <a:avLst>
-              <a:gd name="adj" fmla="val 3333"/>
+              <a:gd name="adj" fmla="val 6667"/>
+            </a:avLst>
+          </a:prstGeom>
+          <a:solidFill>
+            <a:srgbClr val="1C1C28"/>
+          </a:solidFill>
+          <a:ln w="19050">
+            <a:solidFill>
+              <a:srgbClr val="FF7A45"/>
+            </a:solidFill>
+            <a:prstDash val="solid"/>
+          </a:ln>
+        </p:spPr>
+      </p:sp>
+      <p:sp>
+        <p:nvSpPr>
+          <p:cNvPr id="7" name="Text 5"/>
+          <p:cNvSpPr/>
+          <p:nvPr/>
+        </p:nvSpPr>
+        <p:spPr>
+          <a:xfrm>
+            <a:off x="664312" y="2478024"/>
+            <a:ext cx="2011680" cy="274320"/>
+          </a:xfrm>
+          <a:prstGeom prst="rect">
+            <a:avLst/>
+          </a:prstGeom>
+          <a:noFill/>
+          <a:ln/>
+        </p:spPr>
+        <p:txBody>
+          <a:bodyPr wrap="square" rtlCol="0" anchor="ctr"/>
+          <a:lstStyle/>
+          <a:p>
+            <a:pPr algn="ctr" indent="0" marL="0">
+              <a:buNone/>
+            </a:pPr>
+            <a:r>
+              <a:rPr lang="en-US" sz="900" b="1" spc="100" kern="0" dirty="0">
+                <a:solidFill>
+                  <a:srgbClr val="FF7A45"/>
+                </a:solidFill>
+                <a:latin typeface="Consolas" pitchFamily="34" charset="0"/>
+                <a:ea typeface="Consolas" pitchFamily="34" charset="-122"/>
+                <a:cs typeface="Consolas" pitchFamily="34" charset="-120"/>
+              </a:rPr>
+              <a:t>HUMAN</a:t>
+            </a:r>
+            <a:endParaRPr lang="en-US" sz="900" dirty="0"/>
+          </a:p>
+        </p:txBody>
+      </p:sp>
+      <p:sp>
+        <p:nvSpPr>
+          <p:cNvPr id="8" name="Text 6"/>
+          <p:cNvSpPr/>
+          <p:nvPr/>
+        </p:nvSpPr>
+        <p:spPr>
+          <a:xfrm>
+            <a:off x="737464" y="2788920"/>
+            <a:ext cx="1865376" cy="1097280"/>
+          </a:xfrm>
+          <a:prstGeom prst="rect">
+            <a:avLst/>
+          </a:prstGeom>
+          <a:noFill/>
+          <a:ln/>
+        </p:spPr>
+        <p:txBody>
+          <a:bodyPr wrap="square" rtlCol="0" anchor="ctr"/>
+          <a:lstStyle/>
+          <a:p>
+            <a:pPr algn="ctr" indent="0" marL="0">
+              <a:lnSpc>
+                <a:spcPts val="1600"/>
+              </a:lnSpc>
+              <a:buNone/>
+            </a:pPr>
+            <a:r>
+              <a:rPr lang="en-US" sz="1250" b="1" dirty="0">
+                <a:solidFill>
+                  <a:srgbClr val="F5F5F7"/>
+                </a:solidFill>
+                <a:latin typeface="Pretendard" pitchFamily="34" charset="0"/>
+                <a:ea typeface="Pretendard" pitchFamily="34" charset="-122"/>
+                <a:cs typeface="Pretendard" pitchFamily="34" charset="-120"/>
+              </a:rPr>
+              <a:t>별점 + 코멘트</a:t>
+            </a:r>
+            <a:endParaRPr lang="en-US" sz="1250" dirty="0"/>
+          </a:p>
+        </p:txBody>
+      </p:sp>
+      <p:sp>
+        <p:nvSpPr>
+          <p:cNvPr id="9" name="Text 7"/>
+          <p:cNvSpPr/>
+          <p:nvPr/>
+        </p:nvSpPr>
+        <p:spPr>
+          <a:xfrm>
+            <a:off x="2639416" y="2331720"/>
+            <a:ext cx="274320" cy="1645920"/>
+          </a:xfrm>
+          <a:prstGeom prst="rect">
+            <a:avLst/>
+          </a:prstGeom>
+          <a:noFill/>
+          <a:ln/>
+        </p:spPr>
+        <p:txBody>
+          <a:bodyPr wrap="square" rtlCol="0" anchor="ctr"/>
+          <a:lstStyle/>
+          <a:p>
+            <a:pPr algn="ctr" indent="0" marL="0">
+              <a:buNone/>
+            </a:pPr>
+            <a:r>
+              <a:rPr lang="en-US" sz="1700" dirty="0">
+                <a:solidFill>
+                  <a:srgbClr val="FF7A45"/>
+                </a:solidFill>
+                <a:latin typeface="Pretendard" pitchFamily="34" charset="0"/>
+                <a:ea typeface="Pretendard" pitchFamily="34" charset="-122"/>
+                <a:cs typeface="Pretendard" pitchFamily="34" charset="-120"/>
+              </a:rPr>
+              <a:t>→</a:t>
+            </a:r>
+            <a:endParaRPr lang="en-US" sz="1700" dirty="0"/>
+          </a:p>
+        </p:txBody>
+      </p:sp>
+      <p:sp>
+        <p:nvSpPr>
+          <p:cNvPr id="10" name="Shape 8"/>
+          <p:cNvSpPr/>
+          <p:nvPr/>
+        </p:nvSpPr>
+        <p:spPr>
+          <a:xfrm>
+            <a:off x="2877160" y="2331720"/>
+            <a:ext cx="2011680" cy="1645920"/>
+          </a:xfrm>
+          <a:prstGeom prst="roundRect">
+            <a:avLst>
+              <a:gd name="adj" fmla="val 6667"/>
+            </a:avLst>
+          </a:prstGeom>
+          <a:solidFill>
+            <a:srgbClr val="181822"/>
+          </a:solidFill>
+          <a:ln w="12700">
+            <a:solidFill>
+              <a:srgbClr val="2C2C3C"/>
+            </a:solidFill>
+            <a:prstDash val="solid"/>
+          </a:ln>
+        </p:spPr>
+      </p:sp>
+      <p:sp>
+        <p:nvSpPr>
+          <p:cNvPr id="11" name="Text 9"/>
+          <p:cNvSpPr/>
+          <p:nvPr/>
+        </p:nvSpPr>
+        <p:spPr>
+          <a:xfrm>
+            <a:off x="2877160" y="2478024"/>
+            <a:ext cx="2011680" cy="274320"/>
+          </a:xfrm>
+          <a:prstGeom prst="rect">
+            <a:avLst/>
+          </a:prstGeom>
+          <a:noFill/>
+          <a:ln/>
+        </p:spPr>
+        <p:txBody>
+          <a:bodyPr wrap="square" rtlCol="0" anchor="ctr"/>
+          <a:lstStyle/>
+          <a:p>
+            <a:pPr algn="ctr" indent="0" marL="0">
+              <a:buNone/>
+            </a:pPr>
+            <a:r>
+              <a:rPr lang="en-US" sz="900" b="1" spc="100" kern="0" dirty="0">
+                <a:solidFill>
+                  <a:srgbClr val="6E6E80"/>
+                </a:solidFill>
+                <a:latin typeface="Consolas" pitchFamily="34" charset="0"/>
+                <a:ea typeface="Consolas" pitchFamily="34" charset="-122"/>
+                <a:cs typeface="Consolas" pitchFamily="34" charset="-120"/>
+              </a:rPr>
+              <a:t>HUMAN_CRITIC</a:t>
+            </a:r>
+            <a:endParaRPr lang="en-US" sz="900" dirty="0"/>
+          </a:p>
+        </p:txBody>
+      </p:sp>
+      <p:sp>
+        <p:nvSpPr>
+          <p:cNvPr id="12" name="Text 10"/>
+          <p:cNvSpPr/>
+          <p:nvPr/>
+        </p:nvSpPr>
+        <p:spPr>
+          <a:xfrm>
+            <a:off x="2950312" y="2788920"/>
+            <a:ext cx="1865376" cy="1097280"/>
+          </a:xfrm>
+          <a:prstGeom prst="rect">
+            <a:avLst/>
+          </a:prstGeom>
+          <a:noFill/>
+          <a:ln/>
+        </p:spPr>
+        <p:txBody>
+          <a:bodyPr wrap="square" rtlCol="0" anchor="ctr"/>
+          <a:lstStyle/>
+          <a:p>
+            <a:pPr algn="ctr" indent="0" marL="0">
+              <a:lnSpc>
+                <a:spcPts val="1600"/>
+              </a:lnSpc>
+              <a:buNone/>
+            </a:pPr>
+            <a:r>
+              <a:rPr lang="en-US" sz="1250" b="1" dirty="0">
+                <a:solidFill>
+                  <a:srgbClr val="F5F5F7"/>
+                </a:solidFill>
+                <a:latin typeface="Pretendard" pitchFamily="34" charset="0"/>
+                <a:ea typeface="Pretendard" pitchFamily="34" charset="-122"/>
+                <a:cs typeface="Pretendard" pitchFamily="34" charset="-120"/>
+              </a:rPr>
+              <a:t>critique로</a:t>
+            </a:r>
+            <a:endParaRPr lang="en-US" sz="1250" dirty="0"/>
+          </a:p>
+          <a:p>
+            <a:pPr algn="ctr" indent="0" marL="0">
+              <a:lnSpc>
+                <a:spcPts val="1600"/>
+              </a:lnSpc>
+              <a:buNone/>
+            </a:pPr>
+            <a:r>
+              <a:rPr lang="en-US" sz="1250" b="1" dirty="0">
+                <a:solidFill>
+                  <a:srgbClr val="F5F5F7"/>
+                </a:solidFill>
+                <a:latin typeface="Pretendard" pitchFamily="34" charset="0"/>
+                <a:ea typeface="Pretendard" pitchFamily="34" charset="-122"/>
+                <a:cs typeface="Pretendard" pitchFamily="34" charset="-120"/>
+              </a:rPr>
+              <a:t>변환</a:t>
+            </a:r>
+            <a:endParaRPr lang="en-US" sz="1250" dirty="0"/>
+          </a:p>
+        </p:txBody>
+      </p:sp>
+      <p:sp>
+        <p:nvSpPr>
+          <p:cNvPr id="13" name="Text 11"/>
+          <p:cNvSpPr/>
+          <p:nvPr/>
+        </p:nvSpPr>
+        <p:spPr>
+          <a:xfrm>
+            <a:off x="4852264" y="2331720"/>
+            <a:ext cx="274320" cy="1645920"/>
+          </a:xfrm>
+          <a:prstGeom prst="rect">
+            <a:avLst/>
+          </a:prstGeom>
+          <a:noFill/>
+          <a:ln/>
+        </p:spPr>
+        <p:txBody>
+          <a:bodyPr wrap="square" rtlCol="0" anchor="ctr"/>
+          <a:lstStyle/>
+          <a:p>
+            <a:pPr algn="ctr" indent="0" marL="0">
+              <a:buNone/>
+            </a:pPr>
+            <a:r>
+              <a:rPr lang="en-US" sz="1700" dirty="0">
+                <a:solidFill>
+                  <a:srgbClr val="FF7A45"/>
+                </a:solidFill>
+                <a:latin typeface="Pretendard" pitchFamily="34" charset="0"/>
+                <a:ea typeface="Pretendard" pitchFamily="34" charset="-122"/>
+                <a:cs typeface="Pretendard" pitchFamily="34" charset="-120"/>
+              </a:rPr>
+              <a:t>→</a:t>
+            </a:r>
+            <a:endParaRPr lang="en-US" sz="1700" dirty="0"/>
+          </a:p>
+        </p:txBody>
+      </p:sp>
+      <p:sp>
+        <p:nvSpPr>
+          <p:cNvPr id="14" name="Shape 12"/>
+          <p:cNvSpPr/>
+          <p:nvPr/>
+        </p:nvSpPr>
+        <p:spPr>
+          <a:xfrm>
+            <a:off x="5090008" y="2331720"/>
+            <a:ext cx="2011680" cy="1645920"/>
+          </a:xfrm>
+          <a:prstGeom prst="roundRect">
+            <a:avLst>
+              <a:gd name="adj" fmla="val 6667"/>
+            </a:avLst>
+          </a:prstGeom>
+          <a:solidFill>
+            <a:srgbClr val="181822"/>
+          </a:solidFill>
+          <a:ln w="12700">
+            <a:solidFill>
+              <a:srgbClr val="2C2C3C"/>
+            </a:solidFill>
+            <a:prstDash val="solid"/>
+          </a:ln>
+        </p:spPr>
+      </p:sp>
+      <p:sp>
+        <p:nvSpPr>
+          <p:cNvPr id="15" name="Text 13"/>
+          <p:cNvSpPr/>
+          <p:nvPr/>
+        </p:nvSpPr>
+        <p:spPr>
+          <a:xfrm>
+            <a:off x="5090008" y="2478024"/>
+            <a:ext cx="2011680" cy="274320"/>
+          </a:xfrm>
+          <a:prstGeom prst="rect">
+            <a:avLst/>
+          </a:prstGeom>
+          <a:noFill/>
+          <a:ln/>
+        </p:spPr>
+        <p:txBody>
+          <a:bodyPr wrap="square" rtlCol="0" anchor="ctr"/>
+          <a:lstStyle/>
+          <a:p>
+            <a:pPr algn="ctr" indent="0" marL="0">
+              <a:buNone/>
+            </a:pPr>
+            <a:r>
+              <a:rPr lang="en-US" sz="900" b="1" spc="100" kern="0" dirty="0">
+                <a:solidFill>
+                  <a:srgbClr val="6E6E80"/>
+                </a:solidFill>
+                <a:latin typeface="Consolas" pitchFamily="34" charset="0"/>
+                <a:ea typeface="Consolas" pitchFamily="34" charset="-122"/>
+                <a:cs typeface="Consolas" pitchFamily="34" charset="-120"/>
+              </a:rPr>
+              <a:t>REVISER</a:t>
+            </a:r>
+            <a:endParaRPr lang="en-US" sz="900" dirty="0"/>
+          </a:p>
+        </p:txBody>
+      </p:sp>
+      <p:sp>
+        <p:nvSpPr>
+          <p:cNvPr id="16" name="Text 14"/>
+          <p:cNvSpPr/>
+          <p:nvPr/>
+        </p:nvSpPr>
+        <p:spPr>
+          <a:xfrm>
+            <a:off x="5163160" y="2788920"/>
+            <a:ext cx="1865376" cy="1097280"/>
+          </a:xfrm>
+          <a:prstGeom prst="rect">
+            <a:avLst/>
+          </a:prstGeom>
+          <a:noFill/>
+          <a:ln/>
+        </p:spPr>
+        <p:txBody>
+          <a:bodyPr wrap="square" rtlCol="0" anchor="ctr"/>
+          <a:lstStyle/>
+          <a:p>
+            <a:pPr algn="ctr" indent="0" marL="0">
+              <a:lnSpc>
+                <a:spcPts val="1600"/>
+              </a:lnSpc>
+              <a:buNone/>
+            </a:pPr>
+            <a:r>
+              <a:rPr lang="en-US" sz="1250" b="1" dirty="0">
+                <a:solidFill>
+                  <a:srgbClr val="F5F5F7"/>
+                </a:solidFill>
+                <a:latin typeface="Pretendard" pitchFamily="34" charset="0"/>
+                <a:ea typeface="Pretendard" pitchFamily="34" charset="-122"/>
+                <a:cs typeface="Pretendard" pitchFamily="34" charset="-120"/>
+              </a:rPr>
+              <a:t>수정 지시</a:t>
+            </a:r>
+            <a:endParaRPr lang="en-US" sz="1250" dirty="0"/>
+          </a:p>
+        </p:txBody>
+      </p:sp>
+      <p:sp>
+        <p:nvSpPr>
+          <p:cNvPr id="17" name="Text 15"/>
+          <p:cNvSpPr/>
+          <p:nvPr/>
+        </p:nvSpPr>
+        <p:spPr>
+          <a:xfrm>
+            <a:off x="7065112" y="2331720"/>
+            <a:ext cx="274320" cy="1645920"/>
+          </a:xfrm>
+          <a:prstGeom prst="rect">
+            <a:avLst/>
+          </a:prstGeom>
+          <a:noFill/>
+          <a:ln/>
+        </p:spPr>
+        <p:txBody>
+          <a:bodyPr wrap="square" rtlCol="0" anchor="ctr"/>
+          <a:lstStyle/>
+          <a:p>
+            <a:pPr algn="ctr" indent="0" marL="0">
+              <a:buNone/>
+            </a:pPr>
+            <a:r>
+              <a:rPr lang="en-US" sz="1700" dirty="0">
+                <a:solidFill>
+                  <a:srgbClr val="FF7A45"/>
+                </a:solidFill>
+                <a:latin typeface="Pretendard" pitchFamily="34" charset="0"/>
+                <a:ea typeface="Pretendard" pitchFamily="34" charset="-122"/>
+                <a:cs typeface="Pretendard" pitchFamily="34" charset="-120"/>
+              </a:rPr>
+              <a:t>→</a:t>
+            </a:r>
+            <a:endParaRPr lang="en-US" sz="1700" dirty="0"/>
+          </a:p>
+        </p:txBody>
+      </p:sp>
+      <p:sp>
+        <p:nvSpPr>
+          <p:cNvPr id="18" name="Shape 16"/>
+          <p:cNvSpPr/>
+          <p:nvPr/>
+        </p:nvSpPr>
+        <p:spPr>
+          <a:xfrm>
+            <a:off x="7302856" y="2331720"/>
+            <a:ext cx="2011680" cy="1645920"/>
+          </a:xfrm>
+          <a:prstGeom prst="roundRect">
+            <a:avLst>
+              <a:gd name="adj" fmla="val 6667"/>
+            </a:avLst>
+          </a:prstGeom>
+          <a:solidFill>
+            <a:srgbClr val="181822"/>
+          </a:solidFill>
+          <a:ln w="12700">
+            <a:solidFill>
+              <a:srgbClr val="2C2C3C"/>
+            </a:solidFill>
+            <a:prstDash val="solid"/>
+          </a:ln>
+        </p:spPr>
+      </p:sp>
+      <p:sp>
+        <p:nvSpPr>
+          <p:cNvPr id="19" name="Text 17"/>
+          <p:cNvSpPr/>
+          <p:nvPr/>
+        </p:nvSpPr>
+        <p:spPr>
+          <a:xfrm>
+            <a:off x="7302856" y="2478024"/>
+            <a:ext cx="2011680" cy="274320"/>
+          </a:xfrm>
+          <a:prstGeom prst="rect">
+            <a:avLst/>
+          </a:prstGeom>
+          <a:noFill/>
+          <a:ln/>
+        </p:spPr>
+        <p:txBody>
+          <a:bodyPr wrap="square" rtlCol="0" anchor="ctr"/>
+          <a:lstStyle/>
+          <a:p>
+            <a:pPr algn="ctr" indent="0" marL="0">
+              <a:buNone/>
+            </a:pPr>
+            <a:r>
+              <a:rPr lang="en-US" sz="900" b="1" spc="100" kern="0" dirty="0">
+                <a:solidFill>
+                  <a:srgbClr val="6E6E80"/>
+                </a:solidFill>
+                <a:latin typeface="Consolas" pitchFamily="34" charset="0"/>
+                <a:ea typeface="Consolas" pitchFamily="34" charset="-122"/>
+                <a:cs typeface="Consolas" pitchFamily="34" charset="-120"/>
+              </a:rPr>
+              <a:t>DESIGNER→IMG</a:t>
+            </a:r>
+            <a:endParaRPr lang="en-US" sz="900" dirty="0"/>
+          </a:p>
+        </p:txBody>
+      </p:sp>
+      <p:sp>
+        <p:nvSpPr>
+          <p:cNvPr id="20" name="Text 18"/>
+          <p:cNvSpPr/>
+          <p:nvPr/>
+        </p:nvSpPr>
+        <p:spPr>
+          <a:xfrm>
+            <a:off x="7376008" y="2788920"/>
+            <a:ext cx="1865376" cy="1097280"/>
+          </a:xfrm>
+          <a:prstGeom prst="rect">
+            <a:avLst/>
+          </a:prstGeom>
+          <a:noFill/>
+          <a:ln/>
+        </p:spPr>
+        <p:txBody>
+          <a:bodyPr wrap="square" rtlCol="0" anchor="ctr"/>
+          <a:lstStyle/>
+          <a:p>
+            <a:pPr algn="ctr" indent="0" marL="0">
+              <a:lnSpc>
+                <a:spcPts val="1600"/>
+              </a:lnSpc>
+              <a:buNone/>
+            </a:pPr>
+            <a:r>
+              <a:rPr lang="en-US" sz="1250" b="1" dirty="0">
+                <a:solidFill>
+                  <a:srgbClr val="F5F5F7"/>
+                </a:solidFill>
+                <a:latin typeface="Pretendard" pitchFamily="34" charset="0"/>
+                <a:ea typeface="Pretendard" pitchFamily="34" charset="-122"/>
+                <a:cs typeface="Pretendard" pitchFamily="34" charset="-120"/>
+              </a:rPr>
+              <a:t>재생성</a:t>
+            </a:r>
+            <a:endParaRPr lang="en-US" sz="1250" dirty="0"/>
+          </a:p>
+        </p:txBody>
+      </p:sp>
+      <p:sp>
+        <p:nvSpPr>
+          <p:cNvPr id="21" name="Text 19"/>
+          <p:cNvSpPr/>
+          <p:nvPr/>
+        </p:nvSpPr>
+        <p:spPr>
+          <a:xfrm>
+            <a:off x="9277960" y="2331720"/>
+            <a:ext cx="274320" cy="1645920"/>
+          </a:xfrm>
+          <a:prstGeom prst="rect">
+            <a:avLst/>
+          </a:prstGeom>
+          <a:noFill/>
+          <a:ln/>
+        </p:spPr>
+        <p:txBody>
+          <a:bodyPr wrap="square" rtlCol="0" anchor="ctr"/>
+          <a:lstStyle/>
+          <a:p>
+            <a:pPr algn="ctr" indent="0" marL="0">
+              <a:buNone/>
+            </a:pPr>
+            <a:r>
+              <a:rPr lang="en-US" sz="1700" dirty="0">
+                <a:solidFill>
+                  <a:srgbClr val="FF7A45"/>
+                </a:solidFill>
+                <a:latin typeface="Pretendard" pitchFamily="34" charset="0"/>
+                <a:ea typeface="Pretendard" pitchFamily="34" charset="-122"/>
+                <a:cs typeface="Pretendard" pitchFamily="34" charset="-120"/>
+              </a:rPr>
+              <a:t>→</a:t>
+            </a:r>
+            <a:endParaRPr lang="en-US" sz="1700" dirty="0"/>
+          </a:p>
+        </p:txBody>
+      </p:sp>
+      <p:sp>
+        <p:nvSpPr>
+          <p:cNvPr id="22" name="Shape 20"/>
+          <p:cNvSpPr/>
+          <p:nvPr/>
+        </p:nvSpPr>
+        <p:spPr>
+          <a:xfrm>
+            <a:off x="9515704" y="2331720"/>
+            <a:ext cx="2011680" cy="1645920"/>
+          </a:xfrm>
+          <a:prstGeom prst="roundRect">
+            <a:avLst>
+              <a:gd name="adj" fmla="val 6667"/>
+            </a:avLst>
+          </a:prstGeom>
+          <a:solidFill>
+            <a:srgbClr val="181822"/>
+          </a:solidFill>
+          <a:ln w="12700">
+            <a:solidFill>
+              <a:srgbClr val="2C2C3C"/>
+            </a:solidFill>
+            <a:prstDash val="solid"/>
+          </a:ln>
+        </p:spPr>
+      </p:sp>
+      <p:sp>
+        <p:nvSpPr>
+          <p:cNvPr id="23" name="Text 21"/>
+          <p:cNvSpPr/>
+          <p:nvPr/>
+        </p:nvSpPr>
+        <p:spPr>
+          <a:xfrm>
+            <a:off x="9515704" y="2478024"/>
+            <a:ext cx="2011680" cy="274320"/>
+          </a:xfrm>
+          <a:prstGeom prst="rect">
+            <a:avLst/>
+          </a:prstGeom>
+          <a:noFill/>
+          <a:ln/>
+        </p:spPr>
+        <p:txBody>
+          <a:bodyPr wrap="square" rtlCol="0" anchor="ctr"/>
+          <a:lstStyle/>
+          <a:p>
+            <a:pPr algn="ctr" indent="0" marL="0">
+              <a:buNone/>
+            </a:pPr>
+            <a:r>
+              <a:rPr lang="en-US" sz="900" b="1" spc="100" kern="0" dirty="0">
+                <a:solidFill>
+                  <a:srgbClr val="6E6E80"/>
+                </a:solidFill>
+                <a:latin typeface="Consolas" pitchFamily="34" charset="0"/>
+                <a:ea typeface="Consolas" pitchFamily="34" charset="-122"/>
+                <a:cs typeface="Consolas" pitchFamily="34" charset="-120"/>
+              </a:rPr>
+              <a:t>ART_DIRECTOR</a:t>
+            </a:r>
+            <a:endParaRPr lang="en-US" sz="900" dirty="0"/>
+          </a:p>
+        </p:txBody>
+      </p:sp>
+      <p:sp>
+        <p:nvSpPr>
+          <p:cNvPr id="24" name="Text 22"/>
+          <p:cNvSpPr/>
+          <p:nvPr/>
+        </p:nvSpPr>
+        <p:spPr>
+          <a:xfrm>
+            <a:off x="9588856" y="2788920"/>
+            <a:ext cx="1865376" cy="1097280"/>
+          </a:xfrm>
+          <a:prstGeom prst="rect">
+            <a:avLst/>
+          </a:prstGeom>
+          <a:noFill/>
+          <a:ln/>
+        </p:spPr>
+        <p:txBody>
+          <a:bodyPr wrap="square" rtlCol="0" anchor="ctr"/>
+          <a:lstStyle/>
+          <a:p>
+            <a:pPr algn="ctr" indent="0" marL="0">
+              <a:lnSpc>
+                <a:spcPts val="1600"/>
+              </a:lnSpc>
+              <a:buNone/>
+            </a:pPr>
+            <a:r>
+              <a:rPr lang="en-US" sz="1250" b="1" dirty="0">
+                <a:solidFill>
+                  <a:srgbClr val="F5F5F7"/>
+                </a:solidFill>
+                <a:latin typeface="Pretendard" pitchFamily="34" charset="0"/>
+                <a:ea typeface="Pretendard" pitchFamily="34" charset="-122"/>
+                <a:cs typeface="Pretendard" pitchFamily="34" charset="-120"/>
+              </a:rPr>
+              <a:t>자동 재채점</a:t>
+            </a:r>
+            <a:endParaRPr lang="en-US" sz="1250" dirty="0"/>
+          </a:p>
+        </p:txBody>
+      </p:sp>
+      <p:sp>
+        <p:nvSpPr>
+          <p:cNvPr id="25" name="Shape 23"/>
+          <p:cNvSpPr/>
+          <p:nvPr/>
+        </p:nvSpPr>
+        <p:spPr>
+          <a:xfrm>
+            <a:off x="822960" y="4251960"/>
+            <a:ext cx="3383280" cy="1691640"/>
+          </a:xfrm>
+          <a:prstGeom prst="roundRect">
+            <a:avLst>
+              <a:gd name="adj" fmla="val 6486"/>
+            </a:avLst>
+          </a:prstGeom>
+          <a:solidFill>
+            <a:srgbClr val="181822"/>
+          </a:solidFill>
+          <a:ln w="12700">
+            <a:solidFill>
+              <a:srgbClr val="5AD19A"/>
+            </a:solidFill>
+            <a:prstDash val="solid"/>
+          </a:ln>
+        </p:spPr>
+      </p:sp>
+      <p:sp>
+        <p:nvSpPr>
+          <p:cNvPr id="26" name="Text 24"/>
+          <p:cNvSpPr/>
+          <p:nvPr/>
+        </p:nvSpPr>
+        <p:spPr>
+          <a:xfrm>
+            <a:off x="1097280" y="4389120"/>
+            <a:ext cx="2834640" cy="365760"/>
+          </a:xfrm>
+          <a:prstGeom prst="rect">
+            <a:avLst/>
+          </a:prstGeom>
+          <a:noFill/>
+          <a:ln/>
+        </p:spPr>
+        <p:txBody>
+          <a:bodyPr wrap="square" rtlCol="0" anchor="ctr"/>
+          <a:lstStyle/>
+          <a:p>
+            <a:pPr indent="0" marL="0">
+              <a:buNone/>
+            </a:pPr>
+            <a:r>
+              <a:rPr lang="en-US" sz="1300" b="1" dirty="0">
+                <a:solidFill>
+                  <a:srgbClr val="5AD19A"/>
+                </a:solidFill>
+                <a:latin typeface="Pretendard" pitchFamily="34" charset="0"/>
+                <a:ea typeface="Pretendard" pitchFamily="34" charset="-122"/>
+                <a:cs typeface="Pretendard" pitchFamily="34" charset="-120"/>
+              </a:rPr>
+              <a:t>① 즉시 반영</a:t>
+            </a:r>
+            <a:endParaRPr lang="en-US" sz="1300" dirty="0"/>
+          </a:p>
+        </p:txBody>
+      </p:sp>
+      <p:sp>
+        <p:nvSpPr>
+          <p:cNvPr id="27" name="Text 25"/>
+          <p:cNvSpPr/>
+          <p:nvPr/>
+        </p:nvSpPr>
+        <p:spPr>
+          <a:xfrm>
+            <a:off x="1097280" y="4800600"/>
+            <a:ext cx="2834640" cy="1051560"/>
+          </a:xfrm>
+          <a:prstGeom prst="rect">
+            <a:avLst/>
+          </a:prstGeom>
+          <a:noFill/>
+          <a:ln/>
+        </p:spPr>
+        <p:txBody>
+          <a:bodyPr wrap="square" rtlCol="0" anchor="ctr"/>
+          <a:lstStyle/>
+          <a:p>
+            <a:pPr marL="152400" indent="-152400">
+              <a:lnSpc>
+                <a:spcPct val="130000"/>
+              </a:lnSpc>
+              <a:buSzPct val="100000"/>
+              <a:buChar char="▸"/>
+            </a:pPr>
+            <a:r>
+              <a:rPr lang="en-US" sz="1100" dirty="0">
+                <a:solidFill>
+                  <a:srgbClr val="F5F5F7"/>
+                </a:solidFill>
+                <a:latin typeface="Pretendard" pitchFamily="34" charset="0"/>
+                <a:ea typeface="Pretendard" pitchFamily="34" charset="-122"/>
+                <a:cs typeface="Pretendard" pitchFamily="34" charset="-120"/>
+              </a:rPr>
+              <a:t>POST /revise → 그 카드만 재생성</a:t>
+            </a:r>
+            <a:endParaRPr lang="en-US" sz="1100" dirty="0"/>
+          </a:p>
+          <a:p>
+            <a:pPr marL="152400" indent="-152400">
+              <a:lnSpc>
+                <a:spcPct val="130000"/>
+              </a:lnSpc>
+              <a:buSzPct val="100000"/>
+              <a:buChar char="▸"/>
+            </a:pPr>
+            <a:r>
+              <a:rPr lang="en-US" sz="1100" dirty="0">
+                <a:solidFill>
+                  <a:srgbClr val="F5F5F7"/>
+                </a:solidFill>
+                <a:latin typeface="Pretendard" pitchFamily="34" charset="0"/>
+                <a:ea typeface="Pretendard" pitchFamily="34" charset="-122"/>
+                <a:cs typeface="Pretendard" pitchFamily="34" charset="-120"/>
+              </a:rPr>
+              <a:t>auto_score before→after 노출</a:t>
+            </a:r>
+            <a:endParaRPr lang="en-US" sz="1100" dirty="0"/>
+          </a:p>
+        </p:txBody>
+      </p:sp>
+      <p:sp>
+        <p:nvSpPr>
+          <p:cNvPr id="28" name="Shape 26"/>
+          <p:cNvSpPr/>
+          <p:nvPr/>
+        </p:nvSpPr>
+        <p:spPr>
+          <a:xfrm>
+            <a:off x="4434840" y="4251960"/>
+            <a:ext cx="3383280" cy="1691640"/>
+          </a:xfrm>
+          <a:prstGeom prst="roundRect">
+            <a:avLst>
+              <a:gd name="adj" fmla="val 6486"/>
             </a:avLst>
           </a:prstGeom>
           <a:solidFill>
@@ -5006,13 +5975,13 @@
       </p:sp>
       <p:sp>
         <p:nvSpPr>
-          <p:cNvPr id="7" name="Text 5"/>
-          <p:cNvSpPr/>
-          <p:nvPr/>
-        </p:nvSpPr>
-        <p:spPr>
-          <a:xfrm>
-            <a:off x="1097280" y="2560320"/>
+          <p:cNvPr id="29" name="Text 27"/>
+          <p:cNvSpPr/>
+          <p:nvPr/>
+        </p:nvSpPr>
+        <p:spPr>
+          <a:xfrm>
+            <a:off x="4709160" y="4389120"/>
             <a:ext cx="2834640" cy="365760"/>
           </a:xfrm>
           <a:prstGeom prst="rect">
@@ -5029,7 +5998,7 @@
               <a:buNone/>
             </a:pPr>
             <a:r>
-              <a:rPr lang="en-US" sz="1500" b="1" dirty="0">
+              <a:rPr lang="en-US" sz="1300" b="1" dirty="0">
                 <a:solidFill>
                   <a:srgbClr val="FF7A45"/>
                 </a:solidFill>
@@ -5037,42 +6006,42 @@
                 <a:ea typeface="Pretendard" pitchFamily="34" charset="-122"/>
                 <a:cs typeface="Pretendard" pitchFamily="34" charset="-120"/>
               </a:rPr>
-              <a:t>모델</a:t>
-            </a:r>
-            <a:endParaRPr lang="en-US" sz="1500" dirty="0"/>
-          </a:p>
-        </p:txBody>
-      </p:sp>
-      <p:sp>
-        <p:nvSpPr>
-          <p:cNvPr id="8" name="Text 6"/>
-          <p:cNvSpPr/>
-          <p:nvPr/>
-        </p:nvSpPr>
-        <p:spPr>
-          <a:xfrm>
-            <a:off x="1097280" y="3063240"/>
-            <a:ext cx="2834640" cy="2468880"/>
-          </a:xfrm>
-          <a:prstGeom prst="rect">
-            <a:avLst/>
-          </a:prstGeom>
-          <a:noFill/>
-          <a:ln/>
-        </p:spPr>
-        <p:txBody>
-          <a:bodyPr wrap="square" rtlCol="0" anchor="ctr"/>
-          <a:lstStyle/>
-          <a:p>
-            <a:pPr marL="177800" indent="-177800">
+              <a:t>② 수집</a:t>
+            </a:r>
+            <a:endParaRPr lang="en-US" sz="1300" dirty="0"/>
+          </a:p>
+        </p:txBody>
+      </p:sp>
+      <p:sp>
+        <p:nvSpPr>
+          <p:cNvPr id="30" name="Text 28"/>
+          <p:cNvSpPr/>
+          <p:nvPr/>
+        </p:nvSpPr>
+        <p:spPr>
+          <a:xfrm>
+            <a:off x="4709160" y="4800600"/>
+            <a:ext cx="2834640" cy="1051560"/>
+          </a:xfrm>
+          <a:prstGeom prst="rect">
+            <a:avLst/>
+          </a:prstGeom>
+          <a:noFill/>
+          <a:ln/>
+        </p:spPr>
+        <p:txBody>
+          <a:bodyPr wrap="square" rtlCol="0" anchor="ctr"/>
+          <a:lstStyle/>
+          <a:p>
+            <a:pPr marL="152400" indent="-152400">
               <a:lnSpc>
-                <a:spcPct val="135000"/>
+                <a:spcPct val="130000"/>
               </a:lnSpc>
               <a:buSzPct val="100000"/>
               <a:buChar char="▸"/>
             </a:pPr>
             <a:r>
-              <a:rPr lang="en-US" sz="1250" dirty="0">
+              <a:rPr lang="en-US" sz="1100" dirty="0">
                 <a:solidFill>
                   <a:srgbClr val="F5F5F7"/>
                 </a:solidFill>
@@ -5080,20 +6049,20 @@
                 <a:ea typeface="Pretendard" pitchFamily="34" charset="-122"/>
                 <a:cs typeface="Pretendard" pitchFamily="34" charset="-120"/>
               </a:rPr>
-              <a:t>Qwen 최신 모델이 GPT 능가(영어)</a:t>
-            </a:r>
-            <a:endParaRPr lang="en-US" sz="1250" dirty="0"/>
-          </a:p>
-          <a:p>
-            <a:pPr marL="177800" indent="-177800">
+              <a:t>feedback_store JSONL (DB 불필요)</a:t>
+            </a:r>
+            <a:endParaRPr lang="en-US" sz="1100" dirty="0"/>
+          </a:p>
+          <a:p>
+            <a:pPr marL="152400" indent="-152400">
               <a:lnSpc>
-                <a:spcPct val="135000"/>
+                <a:spcPct val="130000"/>
               </a:lnSpc>
               <a:buSzPct val="100000"/>
               <a:buChar char="▸"/>
             </a:pPr>
             <a:r>
-              <a:rPr lang="en-US" sz="1250" dirty="0">
+              <a:rPr lang="en-US" sz="1100" dirty="0">
                 <a:solidFill>
                   <a:srgbClr val="F5F5F7"/>
                 </a:solidFill>
@@ -5101,47 +6070,26 @@
                 <a:ea typeface="Pretendard" pitchFamily="34" charset="-122"/>
                 <a:cs typeface="Pretendard" pitchFamily="34" charset="-120"/>
               </a:rPr>
-              <a:t>한국어에서도 그럴지 검증 필요</a:t>
-            </a:r>
-            <a:endParaRPr lang="en-US" sz="1250" dirty="0"/>
-          </a:p>
-          <a:p>
-            <a:pPr marL="177800" indent="-177800">
-              <a:lnSpc>
-                <a:spcPct val="135000"/>
-              </a:lnSpc>
-              <a:buSzPct val="100000"/>
-              <a:buChar char="▸"/>
-            </a:pPr>
-            <a:r>
-              <a:rPr lang="en-US" sz="1250" dirty="0">
-                <a:solidFill>
-                  <a:srgbClr val="F5F5F7"/>
-                </a:solidFill>
-                <a:latin typeface="Pretendard" pitchFamily="34" charset="0"/>
-                <a:ea typeface="Pretendard" pitchFamily="34" charset="-122"/>
-                <a:cs typeface="Pretendard" pitchFamily="34" charset="-120"/>
-              </a:rPr>
-              <a:t>태스크별 모델 env로 교체 가능하게 설계됨</a:t>
-            </a:r>
-            <a:endParaRPr lang="en-US" sz="1250" dirty="0"/>
-          </a:p>
-        </p:txBody>
-      </p:sp>
-      <p:sp>
-        <p:nvSpPr>
-          <p:cNvPr id="9" name="Shape 7"/>
-          <p:cNvSpPr/>
-          <p:nvPr/>
-        </p:nvSpPr>
-        <p:spPr>
-          <a:xfrm>
-            <a:off x="4434840" y="2377440"/>
-            <a:ext cx="3383280" cy="3291840"/>
+              <a:t>편집비용·선호 데이터 적재</a:t>
+            </a:r>
+            <a:endParaRPr lang="en-US" sz="1100" dirty="0"/>
+          </a:p>
+        </p:txBody>
+      </p:sp>
+      <p:sp>
+        <p:nvSpPr>
+          <p:cNvPr id="31" name="Shape 29"/>
+          <p:cNvSpPr/>
+          <p:nvPr/>
+        </p:nvSpPr>
+        <p:spPr>
+          <a:xfrm>
+            <a:off x="8046720" y="4251960"/>
+            <a:ext cx="3383280" cy="1691640"/>
           </a:xfrm>
           <a:prstGeom prst="roundRect">
             <a:avLst>
-              <a:gd name="adj" fmla="val 3333"/>
+              <a:gd name="adj" fmla="val 6486"/>
             </a:avLst>
           </a:prstGeom>
           <a:solidFill>
@@ -5157,13 +6105,13 @@
       </p:sp>
       <p:sp>
         <p:nvSpPr>
-          <p:cNvPr id="10" name="Text 8"/>
-          <p:cNvSpPr/>
-          <p:nvPr/>
-        </p:nvSpPr>
-        <p:spPr>
-          <a:xfrm>
-            <a:off x="4709160" y="2560320"/>
+          <p:cNvPr id="32" name="Text 30"/>
+          <p:cNvSpPr/>
+          <p:nvPr/>
+        </p:nvSpPr>
+        <p:spPr>
+          <a:xfrm>
+            <a:off x="8321040" y="4389120"/>
             <a:ext cx="2834640" cy="365760"/>
           </a:xfrm>
           <a:prstGeom prst="rect">
@@ -5180,7 +6128,7 @@
               <a:buNone/>
             </a:pPr>
             <a:r>
-              <a:rPr lang="en-US" sz="1500" b="1" dirty="0">
+              <a:rPr lang="en-US" sz="1300" b="1" dirty="0">
                 <a:solidFill>
                   <a:srgbClr val="A855F7"/>
                 </a:solidFill>
@@ -5188,42 +6136,42 @@
                 <a:ea typeface="Pretendard" pitchFamily="34" charset="-122"/>
                 <a:cs typeface="Pretendard" pitchFamily="34" charset="-120"/>
               </a:rPr>
-              <a:t>저작권·데이터</a:t>
-            </a:r>
-            <a:endParaRPr lang="en-US" sz="1500" dirty="0"/>
-          </a:p>
-        </p:txBody>
-      </p:sp>
-      <p:sp>
-        <p:nvSpPr>
-          <p:cNvPr id="11" name="Text 9"/>
-          <p:cNvSpPr/>
-          <p:nvPr/>
-        </p:nvSpPr>
-        <p:spPr>
-          <a:xfrm>
-            <a:off x="4709160" y="3063240"/>
-            <a:ext cx="2834640" cy="2468880"/>
-          </a:xfrm>
-          <a:prstGeom prst="rect">
-            <a:avLst/>
-          </a:prstGeom>
-          <a:noFill/>
-          <a:ln/>
-        </p:spPr>
-        <p:txBody>
-          <a:bodyPr wrap="square" rtlCol="0" anchor="ctr"/>
-          <a:lstStyle/>
-          <a:p>
-            <a:pPr marL="177800" indent="-177800">
+              <a:t>③ 향후 개선</a:t>
+            </a:r>
+            <a:endParaRPr lang="en-US" sz="1300" dirty="0"/>
+          </a:p>
+        </p:txBody>
+      </p:sp>
+      <p:sp>
+        <p:nvSpPr>
+          <p:cNvPr id="33" name="Text 31"/>
+          <p:cNvSpPr/>
+          <p:nvPr/>
+        </p:nvSpPr>
+        <p:spPr>
+          <a:xfrm>
+            <a:off x="8321040" y="4800600"/>
+            <a:ext cx="2834640" cy="1051560"/>
+          </a:xfrm>
+          <a:prstGeom prst="rect">
+            <a:avLst/>
+          </a:prstGeom>
+          <a:noFill/>
+          <a:ln/>
+        </p:spPr>
+        <p:txBody>
+          <a:bodyPr wrap="square" rtlCol="0" anchor="ctr"/>
+          <a:lstStyle/>
+          <a:p>
+            <a:pPr marL="152400" indent="-152400">
               <a:lnSpc>
-                <a:spcPct val="135000"/>
+                <a:spcPct val="130000"/>
               </a:lnSpc>
               <a:buSzPct val="100000"/>
               <a:buChar char="▸"/>
             </a:pPr>
             <a:r>
-              <a:rPr lang="en-US" sz="1250" dirty="0">
+              <a:rPr lang="en-US" sz="1100" dirty="0">
                 <a:solidFill>
                   <a:srgbClr val="F5F5F7"/>
                 </a:solidFill>
@@ -5231,20 +6179,20 @@
                 <a:ea typeface="Pretendard" pitchFamily="34" charset="-122"/>
                 <a:cs typeface="Pretendard" pitchFamily="34" charset="-120"/>
               </a:rPr>
-              <a:t>합성 시 원본 디자인 저작권 이슈</a:t>
-            </a:r>
-            <a:endParaRPr lang="en-US" sz="1250" dirty="0"/>
-          </a:p>
-          <a:p>
-            <a:pPr marL="177800" indent="-177800">
+              <a:t>retriever 선호 재랭킹</a:t>
+            </a:r>
+            <a:endParaRPr lang="en-US" sz="1100" dirty="0"/>
+          </a:p>
+          <a:p>
+            <a:pPr marL="152400" indent="-152400">
               <a:lnSpc>
-                <a:spcPct val="135000"/>
+                <a:spcPct val="130000"/>
               </a:lnSpc>
               <a:buSzPct val="100000"/>
               <a:buChar char="▸"/>
             </a:pPr>
             <a:r>
-              <a:rPr lang="en-US" sz="1250" dirty="0">
+              <a:rPr lang="en-US" sz="1100" dirty="0">
                 <a:solidFill>
                   <a:srgbClr val="F5F5F7"/>
                 </a:solidFill>
@@ -5252,70 +6200,22 @@
                 <a:ea typeface="Pretendard" pitchFamily="34" charset="-122"/>
                 <a:cs typeface="Pretendard" pitchFamily="34" charset="-120"/>
               </a:rPr>
-              <a:t>라이선스 명확한 데이터셋 확대 필요</a:t>
-            </a:r>
-            <a:endParaRPr lang="en-US" sz="1250" dirty="0"/>
-          </a:p>
-          <a:p>
-            <a:pPr marL="177800" indent="-177800">
-              <a:lnSpc>
-                <a:spcPct val="135000"/>
-              </a:lnSpc>
-              <a:buSzPct val="100000"/>
-              <a:buChar char="▸"/>
-            </a:pPr>
-            <a:r>
-              <a:rPr lang="en-US" sz="1250" dirty="0">
-                <a:solidFill>
-                  <a:srgbClr val="F5F5F7"/>
-                </a:solidFill>
-                <a:latin typeface="Pretendard" pitchFamily="34" charset="0"/>
-                <a:ea typeface="Pretendard" pitchFamily="34" charset="-122"/>
-                <a:cs typeface="Pretendard" pitchFamily="34" charset="-120"/>
-              </a:rPr>
-              <a:t>생성-합성 경계의 권리 정리</a:t>
-            </a:r>
-            <a:endParaRPr lang="en-US" sz="1250" dirty="0"/>
-          </a:p>
-        </p:txBody>
-      </p:sp>
-      <p:sp>
-        <p:nvSpPr>
-          <p:cNvPr id="12" name="Shape 10"/>
-          <p:cNvSpPr/>
-          <p:nvPr/>
-        </p:nvSpPr>
-        <p:spPr>
-          <a:xfrm>
-            <a:off x="8046720" y="2377440"/>
-            <a:ext cx="3383280" cy="3291840"/>
-          </a:xfrm>
-          <a:prstGeom prst="roundRect">
-            <a:avLst>
-              <a:gd name="adj" fmla="val 3333"/>
-            </a:avLst>
-          </a:prstGeom>
-          <a:solidFill>
-            <a:srgbClr val="181822"/>
-          </a:solidFill>
-          <a:ln w="12700">
-            <a:solidFill>
-              <a:srgbClr val="FF6B6B"/>
-            </a:solidFill>
-            <a:prstDash val="solid"/>
-          </a:ln>
-        </p:spPr>
-      </p:sp>
-      <p:sp>
-        <p:nvSpPr>
-          <p:cNvPr id="13" name="Text 11"/>
-          <p:cNvSpPr/>
-          <p:nvPr/>
-        </p:nvSpPr>
-        <p:spPr>
-          <a:xfrm>
-            <a:off x="8321040" y="2560320"/>
-            <a:ext cx="2834640" cy="365760"/>
+              <a:t>auto↔human 상관으로 자동평가 검증</a:t>
+            </a:r>
+            <a:endParaRPr lang="en-US" sz="1100" dirty="0"/>
+          </a:p>
+        </p:txBody>
+      </p:sp>
+      <p:sp>
+        <p:nvSpPr>
+          <p:cNvPr id="34" name="Text 32"/>
+          <p:cNvSpPr/>
+          <p:nvPr/>
+        </p:nvSpPr>
+        <p:spPr>
+          <a:xfrm>
+            <a:off x="822960" y="6053328"/>
+            <a:ext cx="10515600" cy="365760"/>
           </a:xfrm>
           <a:prstGeom prst="rect">
             <a:avLst/>
@@ -5331,108 +6231,23 @@
               <a:buNone/>
             </a:pPr>
             <a:r>
-              <a:rPr lang="en-US" sz="1500" b="1" dirty="0">
-                <a:solidFill>
-                  <a:srgbClr val="FF6B6B"/>
-                </a:solidFill>
-                <a:latin typeface="Pretendard" pitchFamily="34" charset="0"/>
-                <a:ea typeface="Pretendard" pitchFamily="34" charset="-122"/>
-                <a:cs typeface="Pretendard" pitchFamily="34" charset="-120"/>
-              </a:rPr>
-              <a:t>기능 안정성</a:t>
-            </a:r>
-            <a:endParaRPr lang="en-US" sz="1500" dirty="0"/>
-          </a:p>
-        </p:txBody>
-      </p:sp>
-      <p:sp>
-        <p:nvSpPr>
-          <p:cNvPr id="14" name="Text 12"/>
-          <p:cNvSpPr/>
-          <p:nvPr/>
-        </p:nvSpPr>
-        <p:spPr>
-          <a:xfrm>
-            <a:off x="8321040" y="3063240"/>
-            <a:ext cx="2834640" cy="2468880"/>
-          </a:xfrm>
-          <a:prstGeom prst="rect">
-            <a:avLst/>
-          </a:prstGeom>
-          <a:noFill/>
-          <a:ln/>
-        </p:spPr>
-        <p:txBody>
-          <a:bodyPr wrap="square" rtlCol="0" anchor="ctr"/>
-          <a:lstStyle/>
-          <a:p>
-            <a:pPr marL="177800" indent="-177800">
-              <a:lnSpc>
-                <a:spcPct val="135000"/>
-              </a:lnSpc>
-              <a:buSzPct val="100000"/>
-              <a:buChar char="▸"/>
-            </a:pPr>
-            <a:r>
-              <a:rPr lang="en-US" sz="1250" dirty="0">
-                <a:solidFill>
-                  <a:srgbClr val="F5F5F7"/>
-                </a:solidFill>
-                <a:latin typeface="Pretendard" pitchFamily="34" charset="0"/>
-                <a:ea typeface="Pretendard" pitchFamily="34" charset="-122"/>
-                <a:cs typeface="Pretendard" pitchFamily="34" charset="-120"/>
-              </a:rPr>
-              <a:t>다중 칸 중 한 곳만 합성 적용되는 버그</a:t>
-            </a:r>
-            <a:endParaRPr lang="en-US" sz="1250" dirty="0"/>
-          </a:p>
-          <a:p>
-            <a:pPr marL="177800" indent="-177800">
-              <a:lnSpc>
-                <a:spcPct val="135000"/>
-              </a:lnSpc>
-              <a:buSzPct val="100000"/>
-              <a:buChar char="▸"/>
-            </a:pPr>
-            <a:r>
-              <a:rPr lang="en-US" sz="1250" dirty="0">
-                <a:solidFill>
-                  <a:srgbClr val="F5F5F7"/>
-                </a:solidFill>
-                <a:latin typeface="Pretendard" pitchFamily="34" charset="0"/>
-                <a:ea typeface="Pretendard" pitchFamily="34" charset="-122"/>
-                <a:cs typeface="Pretendard" pitchFamily="34" charset="-120"/>
-              </a:rPr>
-              <a:t>동시 다중 사진 첨부 불가</a:t>
-            </a:r>
-            <a:endParaRPr lang="en-US" sz="1250" dirty="0"/>
-          </a:p>
-          <a:p>
-            <a:pPr marL="177800" indent="-177800">
-              <a:lnSpc>
-                <a:spcPct val="135000"/>
-              </a:lnSpc>
-              <a:buSzPct val="100000"/>
-              <a:buChar char="▸"/>
-            </a:pPr>
-            <a:r>
-              <a:rPr lang="en-US" sz="1250" dirty="0">
-                <a:solidFill>
-                  <a:srgbClr val="F5F5F7"/>
-                </a:solidFill>
-                <a:latin typeface="Pretendard" pitchFamily="34" charset="0"/>
-                <a:ea typeface="Pretendard" pitchFamily="34" charset="-122"/>
-                <a:cs typeface="Pretendard" pitchFamily="34" charset="-120"/>
-              </a:rPr>
-              <a:t>주제 문구가 합성에 반영 안 되는 현상</a:t>
-            </a:r>
-            <a:endParaRPr lang="en-US" sz="1250" dirty="0"/>
-          </a:p>
-        </p:txBody>
-      </p:sp>
-      <p:sp>
-        <p:nvSpPr>
-          <p:cNvPr id="15" name="Shape 13"/>
+              <a:rPr lang="en-US" sz="1050" i="1" dirty="0">
+                <a:solidFill>
+                  <a:srgbClr val="6E6E80"/>
+                </a:solidFill>
+                <a:latin typeface="Pretendard" pitchFamily="34" charset="0"/>
+                <a:ea typeface="Pretendard" pitchFamily="34" charset="-122"/>
+                <a:cs typeface="Pretendard" pitchFamily="34" charset="-120"/>
+              </a:rPr>
+              <a:t>핵심: art_director 자동 점수를 사람 점수와 상관(Pearson/Spearman)으로 검증 → 자동 평가가 사람 눈을 대체할 수 있음을 입증하고, 그 심사위원을 그대로 루프 보상으로 재사용.</a:t>
+            </a:r>
+            <a:endParaRPr lang="en-US" sz="1050" dirty="0"/>
+          </a:p>
+        </p:txBody>
+      </p:sp>
+      <p:sp>
+        <p:nvSpPr>
+          <p:cNvPr id="35" name="Shape 33"/>
           <p:cNvSpPr/>
           <p:nvPr/>
         </p:nvSpPr>
@@ -5452,7 +6267,7 @@
       </p:sp>
       <p:sp>
         <p:nvSpPr>
-          <p:cNvPr id="16" name="Text 14"/>
+          <p:cNvPr id="36" name="Text 34"/>
           <p:cNvSpPr/>
           <p:nvPr/>
         </p:nvSpPr>
@@ -5491,7 +6306,7 @@
       </p:sp>
       <p:sp>
         <p:nvSpPr>
-          <p:cNvPr id="17" name="Text 15"/>
+          <p:cNvPr id="37" name="Text 35"/>
           <p:cNvSpPr/>
           <p:nvPr/>
         </p:nvSpPr>
@@ -5633,7 +6448,7 @@
                 <a:ea typeface="Pretendard" pitchFamily="34" charset="-122"/>
                 <a:cs typeface="Pretendard" pitchFamily="34" charset="-120"/>
               </a:rPr>
-              <a:t>FUTURE · A2A / MCP 연구 가능성</a:t>
+              <a:t>LIMITATIONS · 개선할 점</a:t>
             </a:r>
             <a:endParaRPr lang="en-US" sz="1300" dirty="0"/>
           </a:p>
@@ -5667,7 +6482,7 @@
               <a:buNone/>
             </a:pPr>
             <a:r>
-              <a:rPr lang="en-US" sz="2500" b="1" dirty="0">
+              <a:rPr lang="en-US" sz="3000" b="1" dirty="0">
                 <a:solidFill>
                   <a:srgbClr val="F5F5F7"/>
                 </a:solidFill>
@@ -5675,26 +6490,9 @@
                 <a:ea typeface="Pretendard" pitchFamily="34" charset="-122"/>
                 <a:cs typeface="Pretendard" pitchFamily="34" charset="-120"/>
               </a:rPr>
-              <a:t>통제 가능한 생성 파이프라인을 </a:t>
-            </a:r>
-            <a:pPr algn="l" indent="0" marL="0">
-              <a:lnSpc>
-                <a:spcPts val="3600"/>
-              </a:lnSpc>
-              <a:buNone/>
-            </a:pPr>
-            <a:r>
-              <a:rPr lang="en-US" sz="2500" b="1" dirty="0">
-                <a:solidFill>
-                  <a:srgbClr val="FF7A45"/>
-                </a:solidFill>
-                <a:latin typeface="Pretendard" pitchFamily="34" charset="0"/>
-                <a:ea typeface="Pretendard" pitchFamily="34" charset="-122"/>
-                <a:cs typeface="Pretendard" pitchFamily="34" charset="-120"/>
-              </a:rPr>
-              <a:t>표준 프로토콜로 노출</a:t>
-            </a:r>
-            <a:endParaRPr lang="en-US" sz="2500" dirty="0"/>
+              <a:t>정직한 한계와 다음 과제</a:t>
+            </a:r>
+            <a:endParaRPr lang="en-US" sz="3000" dirty="0"/>
           </a:p>
         </p:txBody>
       </p:sp>
@@ -5706,8 +6504,8 @@
         </p:nvSpPr>
         <p:spPr>
           <a:xfrm>
-            <a:off x="822960" y="2331720"/>
-            <a:ext cx="5120640" cy="3291840"/>
+            <a:off x="822960" y="2377440"/>
+            <a:ext cx="3383280" cy="3291840"/>
           </a:xfrm>
           <a:prstGeom prst="roundRect">
             <a:avLst>
@@ -5733,8 +6531,8 @@
         </p:nvSpPr>
         <p:spPr>
           <a:xfrm>
-            <a:off x="1097280" y="2487168"/>
-            <a:ext cx="4572000" cy="365760"/>
+            <a:off x="1097280" y="2560320"/>
+            <a:ext cx="2834640" cy="365760"/>
           </a:xfrm>
           <a:prstGeom prst="rect">
             <a:avLst/>
@@ -5750,7 +6548,7 @@
               <a:buNone/>
             </a:pPr>
             <a:r>
-              <a:rPr lang="en-US" sz="1400" b="1" dirty="0">
+              <a:rPr lang="en-US" sz="1500" b="1" dirty="0">
                 <a:solidFill>
                   <a:srgbClr val="FF7A45"/>
                 </a:solidFill>
@@ -5758,9 +6556,9 @@
                 <a:ea typeface="Pretendard" pitchFamily="34" charset="-122"/>
                 <a:cs typeface="Pretendard" pitchFamily="34" charset="-120"/>
               </a:rPr>
-              <a:t>MCP — 도구·자원의 표준화</a:t>
-            </a:r>
-            <a:endParaRPr lang="en-US" sz="1400" dirty="0"/>
+              <a:t>모델</a:t>
+            </a:r>
+            <a:endParaRPr lang="en-US" sz="1500" dirty="0"/>
           </a:p>
         </p:txBody>
       </p:sp>
@@ -5772,8 +6570,8 @@
         </p:nvSpPr>
         <p:spPr>
           <a:xfrm>
-            <a:off x="1143000" y="2971800"/>
-            <a:ext cx="4617720" cy="2560320"/>
+            <a:off x="1097280" y="3063240"/>
+            <a:ext cx="2834640" cy="2468880"/>
           </a:xfrm>
           <a:prstGeom prst="rect">
             <a:avLst/>
@@ -5787,7 +6585,7 @@
           <a:p>
             <a:pPr marL="177800" indent="-177800">
               <a:lnSpc>
-                <a:spcPct val="130000"/>
+                <a:spcPct val="135000"/>
               </a:lnSpc>
               <a:buSzPct val="100000"/>
               <a:buChar char="▸"/>
@@ -5801,14 +6599,14 @@
                 <a:ea typeface="Pretendard" pitchFamily="34" charset="-122"/>
                 <a:cs typeface="Pretendard" pitchFamily="34" charset="-120"/>
               </a:rPr>
-              <a:t>이미 .mcp.json 사용 중 — 자연 확장</a:t>
+              <a:t>Qwen 최신 모델이 GPT 능가(영어)</a:t>
             </a:r>
             <a:endParaRPr lang="en-US" sz="1250" dirty="0"/>
           </a:p>
           <a:p>
             <a:pPr marL="177800" indent="-177800">
               <a:lnSpc>
-                <a:spcPct val="130000"/>
+                <a:spcPct val="135000"/>
               </a:lnSpc>
               <a:buSzPct val="100000"/>
               <a:buChar char="▸"/>
@@ -5822,14 +6620,14 @@
                 <a:ea typeface="Pretendard" pitchFamily="34" charset="-122"/>
                 <a:cs typeface="Pretendard" pitchFamily="34" charset="-120"/>
               </a:rPr>
-              <a:t>생성·편집·평가를 MCP tool로 노출</a:t>
+              <a:t>한국어에서도 그럴지 검증 필요</a:t>
             </a:r>
             <a:endParaRPr lang="en-US" sz="1250" dirty="0"/>
           </a:p>
           <a:p>
             <a:pPr marL="177800" indent="-177800">
               <a:lnSpc>
-                <a:spcPct val="130000"/>
+                <a:spcPct val="135000"/>
               </a:lnSpc>
               <a:buSzPct val="100000"/>
               <a:buChar char="▸"/>
@@ -5843,52 +6641,10 @@
                 <a:ea typeface="Pretendard" pitchFamily="34" charset="-122"/>
                 <a:cs typeface="Pretendard" pitchFamily="34" charset="-120"/>
               </a:rPr>
-              <a:t>브랜드 가이드·폰트·템플릿 DB를 resource로</a:t>
+              <a:t>태스크별 모델 env로 교체 가능하게 설계됨</a:t>
             </a:r>
             <a:endParaRPr lang="en-US" sz="1250" dirty="0"/>
           </a:p>
-          <a:p>
-            <a:pPr marL="177800" indent="-177800">
-              <a:lnSpc>
-                <a:spcPct val="130000"/>
-              </a:lnSpc>
-              <a:buSzPct val="100000"/>
-              <a:buChar char="▸"/>
-            </a:pPr>
-            <a:r>
-              <a:rPr lang="en-US" sz="1250" dirty="0">
-                <a:solidFill>
-                  <a:srgbClr val="F5F5F7"/>
-                </a:solidFill>
-                <a:latin typeface="Pretendard" pitchFamily="34" charset="0"/>
-                <a:ea typeface="Pretendard" pitchFamily="34" charset="-122"/>
-                <a:cs typeface="Pretendard" pitchFamily="34" charset="-120"/>
-              </a:rPr>
-              <a:t>외부 에이전트가 표준 호출로 ‘의도 통제’ 사용</a:t>
-            </a:r>
-            <a:endParaRPr lang="en-US" sz="1250" dirty="0"/>
-          </a:p>
-          <a:p>
-            <a:pPr marL="177800" indent="-177800">
-              <a:lnSpc>
-                <a:spcPct val="130000"/>
-              </a:lnSpc>
-              <a:buSzPct val="100000"/>
-              <a:buChar char="▸"/>
-            </a:pPr>
-            <a:r>
-              <a:rPr lang="en-US" sz="1250" dirty="0">
-                <a:solidFill>
-                  <a:srgbClr val="F5F5F7"/>
-                </a:solidFill>
-                <a:latin typeface="Pretendard" pitchFamily="34" charset="0"/>
-                <a:ea typeface="Pretendard" pitchFamily="34" charset="-122"/>
-                <a:cs typeface="Pretendard" pitchFamily="34" charset="-120"/>
-              </a:rPr>
-              <a:t>기여: 디자인 통제를 도구 인터페이스로 형식화</a:t>
-            </a:r>
-            <a:endParaRPr lang="en-US" sz="1250" dirty="0"/>
-          </a:p>
         </p:txBody>
       </p:sp>
       <p:sp>
@@ -5899,8 +6655,8 @@
         </p:nvSpPr>
         <p:spPr>
           <a:xfrm>
-            <a:off x="6400800" y="2331720"/>
-            <a:ext cx="4937760" cy="3291840"/>
+            <a:off x="4434840" y="2377440"/>
+            <a:ext cx="3383280" cy="3291840"/>
           </a:xfrm>
           <a:prstGeom prst="roundRect">
             <a:avLst>
@@ -5926,8 +6682,8 @@
         </p:nvSpPr>
         <p:spPr>
           <a:xfrm>
-            <a:off x="6675120" y="2487168"/>
-            <a:ext cx="4572000" cy="365760"/>
+            <a:off x="4709160" y="2560320"/>
+            <a:ext cx="2834640" cy="365760"/>
           </a:xfrm>
           <a:prstGeom prst="rect">
             <a:avLst/>
@@ -5943,7 +6699,7 @@
               <a:buNone/>
             </a:pPr>
             <a:r>
-              <a:rPr lang="en-US" sz="1400" b="1" dirty="0">
+              <a:rPr lang="en-US" sz="1500" b="1" dirty="0">
                 <a:solidFill>
                   <a:srgbClr val="A855F7"/>
                 </a:solidFill>
@@ -5951,9 +6707,9 @@
                 <a:ea typeface="Pretendard" pitchFamily="34" charset="-122"/>
                 <a:cs typeface="Pretendard" pitchFamily="34" charset="-120"/>
               </a:rPr>
-              <a:t>A2A — 에이전트 간 협업</a:t>
-            </a:r>
-            <a:endParaRPr lang="en-US" sz="1400" dirty="0"/>
+              <a:t>저작권·데이터</a:t>
+            </a:r>
+            <a:endParaRPr lang="en-US" sz="1500" dirty="0"/>
           </a:p>
         </p:txBody>
       </p:sp>
@@ -5965,8 +6721,8 @@
         </p:nvSpPr>
         <p:spPr>
           <a:xfrm>
-            <a:off x="6720840" y="2971800"/>
-            <a:ext cx="4434840" cy="2560320"/>
+            <a:off x="4709160" y="3063240"/>
+            <a:ext cx="2834640" cy="2468880"/>
           </a:xfrm>
           <a:prstGeom prst="rect">
             <a:avLst/>
@@ -5980,7 +6736,7 @@
           <a:p>
             <a:pPr marL="177800" indent="-177800">
               <a:lnSpc>
-                <a:spcPct val="130000"/>
+                <a:spcPct val="135000"/>
               </a:lnSpc>
               <a:buSzPct val="100000"/>
               <a:buChar char="▸"/>
@@ -5994,14 +6750,14 @@
                 <a:ea typeface="Pretendard" pitchFamily="34" charset="-122"/>
                 <a:cs typeface="Pretendard" pitchFamily="34" charset="-120"/>
               </a:rPr>
-              <a:t>지금은 한 그래프 안의 노드들</a:t>
+              <a:t>합성 시 원본 디자인 저작권 이슈</a:t>
             </a:r>
             <a:endParaRPr lang="en-US" sz="1250" dirty="0"/>
           </a:p>
           <a:p>
             <a:pPr marL="177800" indent="-177800">
               <a:lnSpc>
-                <a:spcPct val="130000"/>
+                <a:spcPct val="135000"/>
               </a:lnSpc>
               <a:buSzPct val="100000"/>
               <a:buChar char="▸"/>
@@ -6015,14 +6771,14 @@
                 <a:ea typeface="Pretendard" pitchFamily="34" charset="-122"/>
                 <a:cs typeface="Pretendard" pitchFamily="34" charset="-120"/>
               </a:rPr>
-              <a:t>planner/designer/critic을 독립 에이전트로 분리</a:t>
+              <a:t>라이선스 명확한 데이터셋 확대 필요</a:t>
             </a:r>
             <a:endParaRPr lang="en-US" sz="1250" dirty="0"/>
           </a:p>
           <a:p>
             <a:pPr marL="177800" indent="-177800">
               <a:lnSpc>
-                <a:spcPct val="130000"/>
+                <a:spcPct val="135000"/>
               </a:lnSpc>
               <a:buSzPct val="100000"/>
               <a:buChar char="▸"/>
@@ -6036,14 +6792,102 @@
                 <a:ea typeface="Pretendard" pitchFamily="34" charset="-122"/>
                 <a:cs typeface="Pretendard" pitchFamily="34" charset="-120"/>
               </a:rPr>
-              <a:t>RQ: 분산 비평-수정 루프의 품질·비용·수렴</a:t>
+              <a:t>생성-합성 경계의 권리 정리</a:t>
             </a:r>
             <a:endParaRPr lang="en-US" sz="1250" dirty="0"/>
           </a:p>
+        </p:txBody>
+      </p:sp>
+      <p:sp>
+        <p:nvSpPr>
+          <p:cNvPr id="12" name="Shape 10"/>
+          <p:cNvSpPr/>
+          <p:nvPr/>
+        </p:nvSpPr>
+        <p:spPr>
+          <a:xfrm>
+            <a:off x="8046720" y="2377440"/>
+            <a:ext cx="3383280" cy="3291840"/>
+          </a:xfrm>
+          <a:prstGeom prst="roundRect">
+            <a:avLst>
+              <a:gd name="adj" fmla="val 3333"/>
+            </a:avLst>
+          </a:prstGeom>
+          <a:solidFill>
+            <a:srgbClr val="181822"/>
+          </a:solidFill>
+          <a:ln w="12700">
+            <a:solidFill>
+              <a:srgbClr val="FF6B6B"/>
+            </a:solidFill>
+            <a:prstDash val="solid"/>
+          </a:ln>
+        </p:spPr>
+      </p:sp>
+      <p:sp>
+        <p:nvSpPr>
+          <p:cNvPr id="13" name="Text 11"/>
+          <p:cNvSpPr/>
+          <p:nvPr/>
+        </p:nvSpPr>
+        <p:spPr>
+          <a:xfrm>
+            <a:off x="8321040" y="2560320"/>
+            <a:ext cx="2834640" cy="365760"/>
+          </a:xfrm>
+          <a:prstGeom prst="rect">
+            <a:avLst/>
+          </a:prstGeom>
+          <a:noFill/>
+          <a:ln/>
+        </p:spPr>
+        <p:txBody>
+          <a:bodyPr wrap="square" rtlCol="0" anchor="ctr"/>
+          <a:lstStyle/>
+          <a:p>
+            <a:pPr indent="0" marL="0">
+              <a:buNone/>
+            </a:pPr>
+            <a:r>
+              <a:rPr lang="en-US" sz="1500" b="1" dirty="0">
+                <a:solidFill>
+                  <a:srgbClr val="FF6B6B"/>
+                </a:solidFill>
+                <a:latin typeface="Pretendard" pitchFamily="34" charset="0"/>
+                <a:ea typeface="Pretendard" pitchFamily="34" charset="-122"/>
+                <a:cs typeface="Pretendard" pitchFamily="34" charset="-120"/>
+              </a:rPr>
+              <a:t>기능 안정성</a:t>
+            </a:r>
+            <a:endParaRPr lang="en-US" sz="1500" dirty="0"/>
+          </a:p>
+        </p:txBody>
+      </p:sp>
+      <p:sp>
+        <p:nvSpPr>
+          <p:cNvPr id="14" name="Text 12"/>
+          <p:cNvSpPr/>
+          <p:nvPr/>
+        </p:nvSpPr>
+        <p:spPr>
+          <a:xfrm>
+            <a:off x="8321040" y="3063240"/>
+            <a:ext cx="2834640" cy="2468880"/>
+          </a:xfrm>
+          <a:prstGeom prst="rect">
+            <a:avLst/>
+          </a:prstGeom>
+          <a:noFill/>
+          <a:ln/>
+        </p:spPr>
+        <p:txBody>
+          <a:bodyPr wrap="square" rtlCol="0" anchor="ctr"/>
+          <a:lstStyle/>
           <a:p>
             <a:pPr marL="177800" indent="-177800">
               <a:lnSpc>
-                <a:spcPct val="130000"/>
+                <a:spcPct val="135000"/>
               </a:lnSpc>
               <a:buSzPct val="100000"/>
               <a:buChar char="▸"/>
@@ -6057,14 +6901,14 @@
                 <a:ea typeface="Pretendard" pitchFamily="34" charset="-122"/>
                 <a:cs typeface="Pretendard" pitchFamily="34" charset="-120"/>
               </a:rPr>
-              <a:t>human-in-the-loop: 사람 디자이너 에이전트 협업</a:t>
+              <a:t>다중 칸 중 한 곳만 합성 적용되는 버그</a:t>
             </a:r>
             <a:endParaRPr lang="en-US" sz="1250" dirty="0"/>
           </a:p>
           <a:p>
             <a:pPr marL="177800" indent="-177800">
               <a:lnSpc>
-                <a:spcPct val="130000"/>
+                <a:spcPct val="135000"/>
               </a:lnSpc>
               <a:buSzPct val="100000"/>
               <a:buChar char="▸"/>
@@ -6072,60 +6916,42 @@
             <a:r>
               <a:rPr lang="en-US" sz="1250" dirty="0">
                 <a:solidFill>
-                  <a:srgbClr val="9A9AA8"/>
-                </a:solidFill>
-                <a:latin typeface="Pretendard" pitchFamily="34" charset="0"/>
-                <a:ea typeface="Pretendard" pitchFamily="34" charset="-122"/>
-                <a:cs typeface="Pretendard" pitchFamily="34" charset="-120"/>
-              </a:rPr>
-              <a:t>솔직히: CV 알고리즘 기여 아님 → 시스템/HCI 트랙</a:t>
+                  <a:srgbClr val="F5F5F7"/>
+                </a:solidFill>
+                <a:latin typeface="Pretendard" pitchFamily="34" charset="0"/>
+                <a:ea typeface="Pretendard" pitchFamily="34" charset="-122"/>
+                <a:cs typeface="Pretendard" pitchFamily="34" charset="-120"/>
+              </a:rPr>
+              <a:t>동시 다중 사진 첨부 불가</a:t>
             </a:r>
             <a:endParaRPr lang="en-US" sz="1250" dirty="0"/>
           </a:p>
-        </p:txBody>
-      </p:sp>
-      <p:sp>
-        <p:nvSpPr>
-          <p:cNvPr id="12" name="Text 10"/>
-          <p:cNvSpPr/>
-          <p:nvPr/>
-        </p:nvSpPr>
-        <p:spPr>
-          <a:xfrm>
-            <a:off x="822960" y="5760720"/>
-            <a:ext cx="10515600" cy="457200"/>
-          </a:xfrm>
-          <a:prstGeom prst="rect">
-            <a:avLst/>
-          </a:prstGeom>
-          <a:noFill/>
-          <a:ln/>
-        </p:spPr>
-        <p:txBody>
-          <a:bodyPr wrap="square" rtlCol="0" anchor="ctr"/>
-          <a:lstStyle/>
-          <a:p>
-            <a:pPr indent="0" marL="0">
-              <a:buNone/>
-            </a:pPr>
-            <a:r>
-              <a:rPr lang="en-US" sz="1100" i="1" dirty="0">
-                <a:solidFill>
-                  <a:srgbClr val="6E6E80"/>
-                </a:solidFill>
-                <a:latin typeface="Pretendard" pitchFamily="34" charset="0"/>
-                <a:ea typeface="Pretendard" pitchFamily="34" charset="-122"/>
-                <a:cs typeface="Pretendard" pitchFamily="34" charset="-120"/>
-              </a:rPr>
-              <a:t>정직한 평가: A2A/MCP는 ‘통제 가능 생성’을 인프라로 확장하는 시스템 기여 — UIST/데모·평가 자동화의 받침대이지, CV 비전 논문의 주축은 아님.</a:t>
-            </a:r>
-            <a:endParaRPr lang="en-US" sz="1100" dirty="0"/>
-          </a:p>
-        </p:txBody>
-      </p:sp>
-      <p:sp>
-        <p:nvSpPr>
-          <p:cNvPr id="13" name="Shape 11"/>
+          <a:p>
+            <a:pPr marL="177800" indent="-177800">
+              <a:lnSpc>
+                <a:spcPct val="135000"/>
+              </a:lnSpc>
+              <a:buSzPct val="100000"/>
+              <a:buChar char="▸"/>
+            </a:pPr>
+            <a:r>
+              <a:rPr lang="en-US" sz="1250" dirty="0">
+                <a:solidFill>
+                  <a:srgbClr val="F5F5F7"/>
+                </a:solidFill>
+                <a:latin typeface="Pretendard" pitchFamily="34" charset="0"/>
+                <a:ea typeface="Pretendard" pitchFamily="34" charset="-122"/>
+                <a:cs typeface="Pretendard" pitchFamily="34" charset="-120"/>
+              </a:rPr>
+              <a:t>주제 문구가 합성에 반영 안 되는 현상</a:t>
+            </a:r>
+            <a:endParaRPr lang="en-US" sz="1250" dirty="0"/>
+          </a:p>
+        </p:txBody>
+      </p:sp>
+      <p:sp>
+        <p:nvSpPr>
+          <p:cNvPr id="15" name="Shape 13"/>
           <p:cNvSpPr/>
           <p:nvPr/>
         </p:nvSpPr>
@@ -6145,7 +6971,7 @@
       </p:sp>
       <p:sp>
         <p:nvSpPr>
-          <p:cNvPr id="14" name="Text 12"/>
+          <p:cNvPr id="16" name="Text 14"/>
           <p:cNvSpPr/>
           <p:nvPr/>
         </p:nvSpPr>
@@ -6184,7 +7010,7 @@
       </p:sp>
       <p:sp>
         <p:nvSpPr>
-          <p:cNvPr id="15" name="Text 13"/>
+          <p:cNvPr id="17" name="Text 15"/>
           <p:cNvSpPr/>
           <p:nvPr/>
         </p:nvSpPr>
@@ -6232,6 +7058,699 @@
 <file path=ppt/slides/slide14.xml><?xml version="1.0" encoding="utf-8"?>
 <p:sld xmlns:a="http://schemas.openxmlformats.org/drawingml/2006/main" xmlns:r="http://schemas.openxmlformats.org/officeDocument/2006/relationships" xmlns:p="http://schemas.openxmlformats.org/presentationml/2006/main">
   <p:cSld name="Slide 14">
+    <p:bg>
+      <p:bgPr>
+        <a:solidFill>
+          <a:srgbClr val="0E0E14"/>
+        </a:solidFill>
+      </p:bgPr>
+    </p:bg>
+    <p:spTree>
+      <p:nvGrpSpPr>
+        <p:cNvPr id="1" name=""/>
+        <p:cNvGrpSpPr/>
+        <p:nvPr/>
+      </p:nvGrpSpPr>
+      <p:grpSpPr>
+        <a:xfrm>
+          <a:off x="0" y="0"/>
+          <a:ext cx="0" cy="0"/>
+          <a:chOff x="0" y="0"/>
+          <a:chExt cx="0" cy="0"/>
+        </a:xfrm>
+      </p:grpSpPr>
+      <p:sp>
+        <p:nvSpPr>
+          <p:cNvPr id="2" name="Shape 0"/>
+          <p:cNvSpPr/>
+          <p:nvPr/>
+        </p:nvSpPr>
+        <p:spPr>
+          <a:xfrm>
+            <a:off x="0" y="0"/>
+            <a:ext cx="6705432" cy="82296"/>
+          </a:xfrm>
+          <a:prstGeom prst="rect">
+            <a:avLst/>
+          </a:prstGeom>
+          <a:solidFill>
+            <a:srgbClr val="FF7A45"/>
+          </a:solidFill>
+          <a:ln/>
+        </p:spPr>
+      </p:sp>
+      <p:sp>
+        <p:nvSpPr>
+          <p:cNvPr id="3" name="Shape 1"/>
+          <p:cNvSpPr/>
+          <p:nvPr/>
+        </p:nvSpPr>
+        <p:spPr>
+          <a:xfrm>
+            <a:off x="6705432" y="0"/>
+            <a:ext cx="5486263" cy="82296"/>
+          </a:xfrm>
+          <a:prstGeom prst="rect">
+            <a:avLst/>
+          </a:prstGeom>
+          <a:solidFill>
+            <a:srgbClr val="A855F7"/>
+          </a:solidFill>
+          <a:ln/>
+        </p:spPr>
+      </p:sp>
+      <p:sp>
+        <p:nvSpPr>
+          <p:cNvPr id="4" name="Text 2"/>
+          <p:cNvSpPr/>
+          <p:nvPr/>
+        </p:nvSpPr>
+        <p:spPr>
+          <a:xfrm>
+            <a:off x="822960" y="566928"/>
+            <a:ext cx="10515600" cy="365760"/>
+          </a:xfrm>
+          <a:prstGeom prst="rect">
+            <a:avLst/>
+          </a:prstGeom>
+          <a:noFill/>
+          <a:ln/>
+        </p:spPr>
+        <p:txBody>
+          <a:bodyPr wrap="square" rtlCol="0" anchor="ctr"/>
+          <a:lstStyle/>
+          <a:p>
+            <a:pPr indent="0" marL="0">
+              <a:buNone/>
+            </a:pPr>
+            <a:r>
+              <a:rPr lang="en-US" sz="1300" b="1" spc="200" kern="0" dirty="0">
+                <a:solidFill>
+                  <a:srgbClr val="FF7A45"/>
+                </a:solidFill>
+                <a:latin typeface="Pretendard" pitchFamily="34" charset="0"/>
+                <a:ea typeface="Pretendard" pitchFamily="34" charset="-122"/>
+                <a:cs typeface="Pretendard" pitchFamily="34" charset="-120"/>
+              </a:rPr>
+              <a:t>FUTURE · A2A / MCP 연구 가능성</a:t>
+            </a:r>
+            <a:endParaRPr lang="en-US" sz="1300" dirty="0"/>
+          </a:p>
+        </p:txBody>
+      </p:sp>
+      <p:sp>
+        <p:nvSpPr>
+          <p:cNvPr id="5" name="Text 3"/>
+          <p:cNvSpPr/>
+          <p:nvPr/>
+        </p:nvSpPr>
+        <p:spPr>
+          <a:xfrm>
+            <a:off x="822960" y="932688"/>
+            <a:ext cx="10515600" cy="1188720"/>
+          </a:xfrm>
+          <a:prstGeom prst="rect">
+            <a:avLst/>
+          </a:prstGeom>
+          <a:noFill/>
+          <a:ln/>
+        </p:spPr>
+        <p:txBody>
+          <a:bodyPr wrap="square" rtlCol="0" anchor="ctr"/>
+          <a:lstStyle/>
+          <a:p>
+            <a:pPr algn="l" indent="0" marL="0">
+              <a:lnSpc>
+                <a:spcPts val="3600"/>
+              </a:lnSpc>
+              <a:buNone/>
+            </a:pPr>
+            <a:r>
+              <a:rPr lang="en-US" sz="2500" b="1" dirty="0">
+                <a:solidFill>
+                  <a:srgbClr val="F5F5F7"/>
+                </a:solidFill>
+                <a:latin typeface="Pretendard" pitchFamily="34" charset="0"/>
+                <a:ea typeface="Pretendard" pitchFamily="34" charset="-122"/>
+                <a:cs typeface="Pretendard" pitchFamily="34" charset="-120"/>
+              </a:rPr>
+              <a:t>통제 가능한 생성 파이프라인을 </a:t>
+            </a:r>
+            <a:pPr algn="l" indent="0" marL="0">
+              <a:lnSpc>
+                <a:spcPts val="3600"/>
+              </a:lnSpc>
+              <a:buNone/>
+            </a:pPr>
+            <a:r>
+              <a:rPr lang="en-US" sz="2500" b="1" dirty="0">
+                <a:solidFill>
+                  <a:srgbClr val="FF7A45"/>
+                </a:solidFill>
+                <a:latin typeface="Pretendard" pitchFamily="34" charset="0"/>
+                <a:ea typeface="Pretendard" pitchFamily="34" charset="-122"/>
+                <a:cs typeface="Pretendard" pitchFamily="34" charset="-120"/>
+              </a:rPr>
+              <a:t>표준 프로토콜로 노출</a:t>
+            </a:r>
+            <a:endParaRPr lang="en-US" sz="2500" dirty="0"/>
+          </a:p>
+        </p:txBody>
+      </p:sp>
+      <p:sp>
+        <p:nvSpPr>
+          <p:cNvPr id="6" name="Shape 4"/>
+          <p:cNvSpPr/>
+          <p:nvPr/>
+        </p:nvSpPr>
+        <p:spPr>
+          <a:xfrm>
+            <a:off x="822960" y="2331720"/>
+            <a:ext cx="5120640" cy="3291840"/>
+          </a:xfrm>
+          <a:prstGeom prst="roundRect">
+            <a:avLst>
+              <a:gd name="adj" fmla="val 3333"/>
+            </a:avLst>
+          </a:prstGeom>
+          <a:solidFill>
+            <a:srgbClr val="181822"/>
+          </a:solidFill>
+          <a:ln w="12700">
+            <a:solidFill>
+              <a:srgbClr val="FF7A45"/>
+            </a:solidFill>
+            <a:prstDash val="solid"/>
+          </a:ln>
+        </p:spPr>
+      </p:sp>
+      <p:sp>
+        <p:nvSpPr>
+          <p:cNvPr id="7" name="Text 5"/>
+          <p:cNvSpPr/>
+          <p:nvPr/>
+        </p:nvSpPr>
+        <p:spPr>
+          <a:xfrm>
+            <a:off x="1097280" y="2487168"/>
+            <a:ext cx="4572000" cy="365760"/>
+          </a:xfrm>
+          <a:prstGeom prst="rect">
+            <a:avLst/>
+          </a:prstGeom>
+          <a:noFill/>
+          <a:ln/>
+        </p:spPr>
+        <p:txBody>
+          <a:bodyPr wrap="square" rtlCol="0" anchor="ctr"/>
+          <a:lstStyle/>
+          <a:p>
+            <a:pPr indent="0" marL="0">
+              <a:buNone/>
+            </a:pPr>
+            <a:r>
+              <a:rPr lang="en-US" sz="1400" b="1" dirty="0">
+                <a:solidFill>
+                  <a:srgbClr val="FF7A45"/>
+                </a:solidFill>
+                <a:latin typeface="Pretendard" pitchFamily="34" charset="0"/>
+                <a:ea typeface="Pretendard" pitchFamily="34" charset="-122"/>
+                <a:cs typeface="Pretendard" pitchFamily="34" charset="-120"/>
+              </a:rPr>
+              <a:t>MCP — 도구·자원의 표준화</a:t>
+            </a:r>
+            <a:endParaRPr lang="en-US" sz="1400" dirty="0"/>
+          </a:p>
+        </p:txBody>
+      </p:sp>
+      <p:sp>
+        <p:nvSpPr>
+          <p:cNvPr id="8" name="Text 6"/>
+          <p:cNvSpPr/>
+          <p:nvPr/>
+        </p:nvSpPr>
+        <p:spPr>
+          <a:xfrm>
+            <a:off x="1143000" y="2971800"/>
+            <a:ext cx="4617720" cy="2560320"/>
+          </a:xfrm>
+          <a:prstGeom prst="rect">
+            <a:avLst/>
+          </a:prstGeom>
+          <a:noFill/>
+          <a:ln/>
+        </p:spPr>
+        <p:txBody>
+          <a:bodyPr wrap="square" rtlCol="0" anchor="ctr"/>
+          <a:lstStyle/>
+          <a:p>
+            <a:pPr marL="177800" indent="-177800">
+              <a:lnSpc>
+                <a:spcPct val="130000"/>
+              </a:lnSpc>
+              <a:buSzPct val="100000"/>
+              <a:buChar char="▸"/>
+            </a:pPr>
+            <a:r>
+              <a:rPr lang="en-US" sz="1250" dirty="0">
+                <a:solidFill>
+                  <a:srgbClr val="F5F5F7"/>
+                </a:solidFill>
+                <a:latin typeface="Pretendard" pitchFamily="34" charset="0"/>
+                <a:ea typeface="Pretendard" pitchFamily="34" charset="-122"/>
+                <a:cs typeface="Pretendard" pitchFamily="34" charset="-120"/>
+              </a:rPr>
+              <a:t>이미 .mcp.json 사용 중 — 자연 확장</a:t>
+            </a:r>
+            <a:endParaRPr lang="en-US" sz="1250" dirty="0"/>
+          </a:p>
+          <a:p>
+            <a:pPr marL="177800" indent="-177800">
+              <a:lnSpc>
+                <a:spcPct val="130000"/>
+              </a:lnSpc>
+              <a:buSzPct val="100000"/>
+              <a:buChar char="▸"/>
+            </a:pPr>
+            <a:r>
+              <a:rPr lang="en-US" sz="1250" dirty="0">
+                <a:solidFill>
+                  <a:srgbClr val="F5F5F7"/>
+                </a:solidFill>
+                <a:latin typeface="Pretendard" pitchFamily="34" charset="0"/>
+                <a:ea typeface="Pretendard" pitchFamily="34" charset="-122"/>
+                <a:cs typeface="Pretendard" pitchFamily="34" charset="-120"/>
+              </a:rPr>
+              <a:t>생성·편집·평가를 MCP tool로 노출</a:t>
+            </a:r>
+            <a:endParaRPr lang="en-US" sz="1250" dirty="0"/>
+          </a:p>
+          <a:p>
+            <a:pPr marL="177800" indent="-177800">
+              <a:lnSpc>
+                <a:spcPct val="130000"/>
+              </a:lnSpc>
+              <a:buSzPct val="100000"/>
+              <a:buChar char="▸"/>
+            </a:pPr>
+            <a:r>
+              <a:rPr lang="en-US" sz="1250" dirty="0">
+                <a:solidFill>
+                  <a:srgbClr val="F5F5F7"/>
+                </a:solidFill>
+                <a:latin typeface="Pretendard" pitchFamily="34" charset="0"/>
+                <a:ea typeface="Pretendard" pitchFamily="34" charset="-122"/>
+                <a:cs typeface="Pretendard" pitchFamily="34" charset="-120"/>
+              </a:rPr>
+              <a:t>브랜드 가이드·폰트·템플릿 DB를 resource로</a:t>
+            </a:r>
+            <a:endParaRPr lang="en-US" sz="1250" dirty="0"/>
+          </a:p>
+          <a:p>
+            <a:pPr marL="177800" indent="-177800">
+              <a:lnSpc>
+                <a:spcPct val="130000"/>
+              </a:lnSpc>
+              <a:buSzPct val="100000"/>
+              <a:buChar char="▸"/>
+            </a:pPr>
+            <a:r>
+              <a:rPr lang="en-US" sz="1250" dirty="0">
+                <a:solidFill>
+                  <a:srgbClr val="F5F5F7"/>
+                </a:solidFill>
+                <a:latin typeface="Pretendard" pitchFamily="34" charset="0"/>
+                <a:ea typeface="Pretendard" pitchFamily="34" charset="-122"/>
+                <a:cs typeface="Pretendard" pitchFamily="34" charset="-120"/>
+              </a:rPr>
+              <a:t>외부 에이전트가 표준 호출로 ‘의도 통제’ 사용</a:t>
+            </a:r>
+            <a:endParaRPr lang="en-US" sz="1250" dirty="0"/>
+          </a:p>
+          <a:p>
+            <a:pPr marL="177800" indent="-177800">
+              <a:lnSpc>
+                <a:spcPct val="130000"/>
+              </a:lnSpc>
+              <a:buSzPct val="100000"/>
+              <a:buChar char="▸"/>
+            </a:pPr>
+            <a:r>
+              <a:rPr lang="en-US" sz="1250" dirty="0">
+                <a:solidFill>
+                  <a:srgbClr val="F5F5F7"/>
+                </a:solidFill>
+                <a:latin typeface="Pretendard" pitchFamily="34" charset="0"/>
+                <a:ea typeface="Pretendard" pitchFamily="34" charset="-122"/>
+                <a:cs typeface="Pretendard" pitchFamily="34" charset="-120"/>
+              </a:rPr>
+              <a:t>기여: 디자인 통제를 도구 인터페이스로 형식화</a:t>
+            </a:r>
+            <a:endParaRPr lang="en-US" sz="1250" dirty="0"/>
+          </a:p>
+        </p:txBody>
+      </p:sp>
+      <p:sp>
+        <p:nvSpPr>
+          <p:cNvPr id="9" name="Shape 7"/>
+          <p:cNvSpPr/>
+          <p:nvPr/>
+        </p:nvSpPr>
+        <p:spPr>
+          <a:xfrm>
+            <a:off x="6400800" y="2331720"/>
+            <a:ext cx="4937760" cy="3291840"/>
+          </a:xfrm>
+          <a:prstGeom prst="roundRect">
+            <a:avLst>
+              <a:gd name="adj" fmla="val 3333"/>
+            </a:avLst>
+          </a:prstGeom>
+          <a:solidFill>
+            <a:srgbClr val="181822"/>
+          </a:solidFill>
+          <a:ln w="12700">
+            <a:solidFill>
+              <a:srgbClr val="A855F7"/>
+            </a:solidFill>
+            <a:prstDash val="solid"/>
+          </a:ln>
+        </p:spPr>
+      </p:sp>
+      <p:sp>
+        <p:nvSpPr>
+          <p:cNvPr id="10" name="Text 8"/>
+          <p:cNvSpPr/>
+          <p:nvPr/>
+        </p:nvSpPr>
+        <p:spPr>
+          <a:xfrm>
+            <a:off x="6675120" y="2487168"/>
+            <a:ext cx="4572000" cy="365760"/>
+          </a:xfrm>
+          <a:prstGeom prst="rect">
+            <a:avLst/>
+          </a:prstGeom>
+          <a:noFill/>
+          <a:ln/>
+        </p:spPr>
+        <p:txBody>
+          <a:bodyPr wrap="square" rtlCol="0" anchor="ctr"/>
+          <a:lstStyle/>
+          <a:p>
+            <a:pPr indent="0" marL="0">
+              <a:buNone/>
+            </a:pPr>
+            <a:r>
+              <a:rPr lang="en-US" sz="1400" b="1" dirty="0">
+                <a:solidFill>
+                  <a:srgbClr val="A855F7"/>
+                </a:solidFill>
+                <a:latin typeface="Pretendard" pitchFamily="34" charset="0"/>
+                <a:ea typeface="Pretendard" pitchFamily="34" charset="-122"/>
+                <a:cs typeface="Pretendard" pitchFamily="34" charset="-120"/>
+              </a:rPr>
+              <a:t>A2A — 에이전트 간 협업</a:t>
+            </a:r>
+            <a:endParaRPr lang="en-US" sz="1400" dirty="0"/>
+          </a:p>
+        </p:txBody>
+      </p:sp>
+      <p:sp>
+        <p:nvSpPr>
+          <p:cNvPr id="11" name="Text 9"/>
+          <p:cNvSpPr/>
+          <p:nvPr/>
+        </p:nvSpPr>
+        <p:spPr>
+          <a:xfrm>
+            <a:off x="6720840" y="2971800"/>
+            <a:ext cx="4434840" cy="2560320"/>
+          </a:xfrm>
+          <a:prstGeom prst="rect">
+            <a:avLst/>
+          </a:prstGeom>
+          <a:noFill/>
+          <a:ln/>
+        </p:spPr>
+        <p:txBody>
+          <a:bodyPr wrap="square" rtlCol="0" anchor="ctr"/>
+          <a:lstStyle/>
+          <a:p>
+            <a:pPr marL="177800" indent="-177800">
+              <a:lnSpc>
+                <a:spcPct val="130000"/>
+              </a:lnSpc>
+              <a:buSzPct val="100000"/>
+              <a:buChar char="▸"/>
+            </a:pPr>
+            <a:r>
+              <a:rPr lang="en-US" sz="1250" dirty="0">
+                <a:solidFill>
+                  <a:srgbClr val="F5F5F7"/>
+                </a:solidFill>
+                <a:latin typeface="Pretendard" pitchFamily="34" charset="0"/>
+                <a:ea typeface="Pretendard" pitchFamily="34" charset="-122"/>
+                <a:cs typeface="Pretendard" pitchFamily="34" charset="-120"/>
+              </a:rPr>
+              <a:t>지금은 한 그래프 안의 노드들</a:t>
+            </a:r>
+            <a:endParaRPr lang="en-US" sz="1250" dirty="0"/>
+          </a:p>
+          <a:p>
+            <a:pPr marL="177800" indent="-177800">
+              <a:lnSpc>
+                <a:spcPct val="130000"/>
+              </a:lnSpc>
+              <a:buSzPct val="100000"/>
+              <a:buChar char="▸"/>
+            </a:pPr>
+            <a:r>
+              <a:rPr lang="en-US" sz="1250" dirty="0">
+                <a:solidFill>
+                  <a:srgbClr val="F5F5F7"/>
+                </a:solidFill>
+                <a:latin typeface="Pretendard" pitchFamily="34" charset="0"/>
+                <a:ea typeface="Pretendard" pitchFamily="34" charset="-122"/>
+                <a:cs typeface="Pretendard" pitchFamily="34" charset="-120"/>
+              </a:rPr>
+              <a:t>planner/designer/critic을 독립 에이전트로 분리</a:t>
+            </a:r>
+            <a:endParaRPr lang="en-US" sz="1250" dirty="0"/>
+          </a:p>
+          <a:p>
+            <a:pPr marL="177800" indent="-177800">
+              <a:lnSpc>
+                <a:spcPct val="130000"/>
+              </a:lnSpc>
+              <a:buSzPct val="100000"/>
+              <a:buChar char="▸"/>
+            </a:pPr>
+            <a:r>
+              <a:rPr lang="en-US" sz="1250" dirty="0">
+                <a:solidFill>
+                  <a:srgbClr val="F5F5F7"/>
+                </a:solidFill>
+                <a:latin typeface="Pretendard" pitchFamily="34" charset="0"/>
+                <a:ea typeface="Pretendard" pitchFamily="34" charset="-122"/>
+                <a:cs typeface="Pretendard" pitchFamily="34" charset="-120"/>
+              </a:rPr>
+              <a:t>RQ: 분산 비평-수정 루프의 품질·비용·수렴</a:t>
+            </a:r>
+            <a:endParaRPr lang="en-US" sz="1250" dirty="0"/>
+          </a:p>
+          <a:p>
+            <a:pPr marL="177800" indent="-177800">
+              <a:lnSpc>
+                <a:spcPct val="130000"/>
+              </a:lnSpc>
+              <a:buSzPct val="100000"/>
+              <a:buChar char="▸"/>
+            </a:pPr>
+            <a:r>
+              <a:rPr lang="en-US" sz="1250" dirty="0">
+                <a:solidFill>
+                  <a:srgbClr val="F5F5F7"/>
+                </a:solidFill>
+                <a:latin typeface="Pretendard" pitchFamily="34" charset="0"/>
+                <a:ea typeface="Pretendard" pitchFamily="34" charset="-122"/>
+                <a:cs typeface="Pretendard" pitchFamily="34" charset="-120"/>
+              </a:rPr>
+              <a:t>human-in-the-loop: 사람 디자이너 에이전트 협업</a:t>
+            </a:r>
+            <a:endParaRPr lang="en-US" sz="1250" dirty="0"/>
+          </a:p>
+          <a:p>
+            <a:pPr marL="177800" indent="-177800">
+              <a:lnSpc>
+                <a:spcPct val="130000"/>
+              </a:lnSpc>
+              <a:buSzPct val="100000"/>
+              <a:buChar char="▸"/>
+            </a:pPr>
+            <a:r>
+              <a:rPr lang="en-US" sz="1250" dirty="0">
+                <a:solidFill>
+                  <a:srgbClr val="9A9AA8"/>
+                </a:solidFill>
+                <a:latin typeface="Pretendard" pitchFamily="34" charset="0"/>
+                <a:ea typeface="Pretendard" pitchFamily="34" charset="-122"/>
+                <a:cs typeface="Pretendard" pitchFamily="34" charset="-120"/>
+              </a:rPr>
+              <a:t>솔직히: CV 알고리즘 기여 아님 → 시스템/HCI 트랙</a:t>
+            </a:r>
+            <a:endParaRPr lang="en-US" sz="1250" dirty="0"/>
+          </a:p>
+        </p:txBody>
+      </p:sp>
+      <p:sp>
+        <p:nvSpPr>
+          <p:cNvPr id="12" name="Text 10"/>
+          <p:cNvSpPr/>
+          <p:nvPr/>
+        </p:nvSpPr>
+        <p:spPr>
+          <a:xfrm>
+            <a:off x="822960" y="5760720"/>
+            <a:ext cx="10515600" cy="457200"/>
+          </a:xfrm>
+          <a:prstGeom prst="rect">
+            <a:avLst/>
+          </a:prstGeom>
+          <a:noFill/>
+          <a:ln/>
+        </p:spPr>
+        <p:txBody>
+          <a:bodyPr wrap="square" rtlCol="0" anchor="ctr"/>
+          <a:lstStyle/>
+          <a:p>
+            <a:pPr indent="0" marL="0">
+              <a:buNone/>
+            </a:pPr>
+            <a:r>
+              <a:rPr lang="en-US" sz="1100" i="1" dirty="0">
+                <a:solidFill>
+                  <a:srgbClr val="6E6E80"/>
+                </a:solidFill>
+                <a:latin typeface="Pretendard" pitchFamily="34" charset="0"/>
+                <a:ea typeface="Pretendard" pitchFamily="34" charset="-122"/>
+                <a:cs typeface="Pretendard" pitchFamily="34" charset="-120"/>
+              </a:rPr>
+              <a:t>정직한 평가: A2A/MCP는 ‘통제 가능 생성’을 인프라로 확장하는 시스템 기여 — UIST/데모·평가 자동화의 받침대이지, CV 비전 논문의 주축은 아님.</a:t>
+            </a:r>
+            <a:endParaRPr lang="en-US" sz="1100" dirty="0"/>
+          </a:p>
+        </p:txBody>
+      </p:sp>
+      <p:sp>
+        <p:nvSpPr>
+          <p:cNvPr id="13" name="Shape 11"/>
+          <p:cNvSpPr/>
+          <p:nvPr/>
+        </p:nvSpPr>
+        <p:spPr>
+          <a:xfrm>
+            <a:off x="822960" y="6327648"/>
+            <a:ext cx="320040" cy="45720"/>
+          </a:xfrm>
+          <a:prstGeom prst="rect">
+            <a:avLst/>
+          </a:prstGeom>
+          <a:solidFill>
+            <a:srgbClr val="FF7A45"/>
+          </a:solidFill>
+          <a:ln/>
+        </p:spPr>
+      </p:sp>
+      <p:sp>
+        <p:nvSpPr>
+          <p:cNvPr id="14" name="Text 12"/>
+          <p:cNvSpPr/>
+          <p:nvPr/>
+        </p:nvSpPr>
+        <p:spPr>
+          <a:xfrm>
+            <a:off x="822960" y="6400800"/>
+            <a:ext cx="7315200" cy="274320"/>
+          </a:xfrm>
+          <a:prstGeom prst="rect">
+            <a:avLst/>
+          </a:prstGeom>
+          <a:noFill/>
+          <a:ln/>
+        </p:spPr>
+        <p:txBody>
+          <a:bodyPr wrap="square" rtlCol="0" anchor="ctr"/>
+          <a:lstStyle/>
+          <a:p>
+            <a:pPr algn="l" indent="0" marL="0">
+              <a:buNone/>
+            </a:pPr>
+            <a:r>
+              <a:rPr lang="en-US" sz="900" dirty="0">
+                <a:solidFill>
+                  <a:srgbClr val="6E6E80"/>
+                </a:solidFill>
+                <a:latin typeface="Pretendard" pitchFamily="34" charset="0"/>
+                <a:ea typeface="Pretendard" pitchFamily="34" charset="-122"/>
+                <a:cs typeface="Pretendard" pitchFamily="34" charset="-120"/>
+              </a:rPr>
+              <a:t>IntentCard · Computer Vision Seminar</a:t>
+            </a:r>
+            <a:endParaRPr lang="en-US" sz="900" dirty="0"/>
+          </a:p>
+        </p:txBody>
+      </p:sp>
+      <p:sp>
+        <p:nvSpPr>
+          <p:cNvPr id="15" name="Text 13"/>
+          <p:cNvSpPr/>
+          <p:nvPr/>
+        </p:nvSpPr>
+        <p:spPr>
+          <a:xfrm>
+            <a:off x="9509760" y="6400800"/>
+            <a:ext cx="1828800" cy="274320"/>
+          </a:xfrm>
+          <a:prstGeom prst="rect">
+            <a:avLst/>
+          </a:prstGeom>
+          <a:noFill/>
+          <a:ln/>
+        </p:spPr>
+        <p:txBody>
+          <a:bodyPr wrap="square" rtlCol="0" anchor="ctr"/>
+          <a:lstStyle/>
+          <a:p>
+            <a:pPr algn="r" indent="0" marL="0">
+              <a:buNone/>
+            </a:pPr>
+            <a:r>
+              <a:rPr lang="en-US" sz="900" dirty="0">
+                <a:solidFill>
+                  <a:srgbClr val="6E6E80"/>
+                </a:solidFill>
+                <a:latin typeface="Pretendard" pitchFamily="34" charset="0"/>
+                <a:ea typeface="Pretendard" pitchFamily="34" charset="-122"/>
+                <a:cs typeface="Pretendard" pitchFamily="34" charset="-120"/>
+              </a:rPr>
+              <a:t>14</a:t>
+            </a:r>
+            <a:endParaRPr lang="en-US" sz="900" dirty="0"/>
+          </a:p>
+        </p:txBody>
+      </p:sp>
+    </p:spTree>
+  </p:cSld>
+  <p:clrMapOvr>
+    <a:masterClrMapping/>
+  </p:clrMapOvr>
+</p:sld>
+</file>
+
+<file path=ppt/slides/slide15.xml><?xml version="1.0" encoding="utf-8"?>
+<p:sld xmlns:a="http://schemas.openxmlformats.org/drawingml/2006/main" xmlns:r="http://schemas.openxmlformats.org/officeDocument/2006/relationships" xmlns:p="http://schemas.openxmlformats.org/presentationml/2006/main">
+  <p:cSld name="Slide 15">
     <p:bg>
       <p:bgPr>
         <a:solidFill>

</xml_diff>